<commit_message>
Rebuild Coverity_Final_Slide_Updated.pptx as pixel-faithful, editable replica of Coverity_Final_Slide.png
- Background = PNG with text glyphs inpainted out (icons/tables/arrows/glows kept)
- 43 editable text boxes positioned/sized to match PNG within +/-3 px (auto-calibrated
  against headless render; per-line DejaVu Sans size fitted to PNG glyph widths)
- Restores PNG truth: $30/hr cost line, single-line footer, MANUAL vs AUTOMATED table,
  isometric report/rules/dispositions diagram
- rebuild_final_slide.py regenerates pptx + preview; preview PNG included

Co-authored-by: arena-agent <297053741+arena-agent@users.noreply.github.com>
</commit_message>
<xml_diff>
--- a/Coverity_Final_Slide_Updated.pptx
+++ b/Coverity_Final_Slide_Updated.pptx
@@ -3081,14 +3081,6 @@
 <file path=ppt/slides/slide1.xml><?xml version="1.0" encoding="utf-8"?>
 <p:sld xmlns:a="http://schemas.openxmlformats.org/drawingml/2006/main" xmlns:p="http://schemas.openxmlformats.org/presentationml/2006/main" xmlns:r="http://schemas.openxmlformats.org/officeDocument/2006/relationships">
   <p:cSld>
-    <p:bg>
-      <p:bgPr>
-        <a:solidFill>
-          <a:srgbClr val="0A0E1A"/>
-        </a:solidFill>
-        <a:effectLst/>
-      </p:bgPr>
-    </p:bg>
     <p:spTree>
       <p:nvGrpSpPr>
         <p:cNvPr id="1" name=""/>
@@ -3096,16 +3088,40 @@
         <p:nvPr/>
       </p:nvGrpSpPr>
       <p:grpSpPr/>
-      <p:sp>
-        <p:nvSpPr>
-          <p:cNvPr id="2" name="TextBox 1"/>
+      <p:pic>
+        <p:nvPicPr>
+          <p:cNvPr id="2" name="Picture 1" descr="slide_bg.png"/>
+          <p:cNvPicPr>
+            <a:picLocks noChangeAspect="1"/>
+          </p:cNvPicPr>
+          <p:nvPr/>
+        </p:nvPicPr>
+        <p:blipFill>
+          <a:blip r:embed="rId2"/>
+          <a:stretch>
+            <a:fillRect/>
+          </a:stretch>
+        </p:blipFill>
+        <p:spPr>
+          <a:xfrm>
+            <a:off x="0" y="0"/>
+            <a:ext cx="12191695" cy="6858000"/>
+          </a:xfrm>
+          <a:prstGeom prst="rect">
+            <a:avLst/>
+          </a:prstGeom>
+        </p:spPr>
+      </p:pic>
+      <p:sp>
+        <p:nvSpPr>
+          <p:cNvPr id="3" name="TextBox 2"/>
           <p:cNvSpPr txBox="1"/>
           <p:nvPr/>
         </p:nvSpPr>
         <p:spPr>
           <a:xfrm>
-            <a:off x="365760" y="137160"/>
-            <a:ext cx="2286000" cy="365760"/>
+            <a:off x="400050" y="151804"/>
+            <a:ext cx="3867149" cy="550068"/>
           </a:xfrm>
           <a:prstGeom prst="rect">
             <a:avLst/>
@@ -3113,35 +3129,50 @@
           <a:noFill/>
         </p:spPr>
         <p:txBody>
-          <a:bodyPr wrap="square" anchor="t">
+          <a:bodyPr wrap="none" anchor="t" lIns="0" rIns="0" tIns="0" bIns="0">
             <a:spAutoFit/>
           </a:bodyPr>
           <a:lstStyle/>
           <a:p>
             <a:pPr algn="l">
-              <a:defRPr sz="1800" b="1">
-                <a:solidFill>
-                  <a:srgbClr val="FFFFFF"/>
-                </a:solidFill>
-                <a:latin typeface="Calibri"/>
-              </a:defRPr>
+              <a:spcBef>
+                <a:spcPts val="0"/>
+              </a:spcBef>
+              <a:spcAft>
+                <a:spcPts val="0"/>
+              </a:spcAft>
             </a:pPr>
             <a:r>
-              <a:t>Honeywell</a:t>
-            </a:r>
-          </a:p>
-        </p:txBody>
-      </p:sp>
-      <p:sp>
-        <p:nvSpPr>
-          <p:cNvPr id="3" name="TextBox 2"/>
+              <a:rPr sz="1968" b="1">
+                <a:solidFill>
+                  <a:srgbClr val="F9FBFC"/>
+                </a:solidFill>
+                <a:latin typeface="DejaVu Sans"/>
+              </a:rPr>
+              <a:t>Honeywell </a:t>
+            </a:r>
+            <a:r>
+              <a:rPr sz="1968" b="0">
+                <a:solidFill>
+                  <a:srgbClr val="F9FBFC"/>
+                </a:solidFill>
+                <a:latin typeface="DejaVu Sans"/>
+              </a:rPr>
+              <a:t>Aerospace</a:t>
+            </a:r>
+          </a:p>
+        </p:txBody>
+      </p:sp>
+      <p:sp>
+        <p:nvSpPr>
+          <p:cNvPr id="4" name="TextBox 3"/>
           <p:cNvSpPr txBox="1"/>
           <p:nvPr/>
         </p:nvSpPr>
         <p:spPr>
           <a:xfrm>
-            <a:off x="365760" y="457200"/>
-            <a:ext cx="2286000" cy="274320"/>
+            <a:off x="10715625" y="205382"/>
+            <a:ext cx="2352675" cy="392906"/>
           </a:xfrm>
           <a:prstGeom prst="rect">
             <a:avLst/>
@@ -3149,65 +3180,28 @@
           <a:noFill/>
         </p:spPr>
         <p:txBody>
-          <a:bodyPr wrap="square" anchor="t">
+          <a:bodyPr wrap="none" anchor="t" lIns="0" rIns="0" tIns="0" bIns="0">
             <a:spAutoFit/>
           </a:bodyPr>
           <a:lstStyle/>
           <a:p>
             <a:pPr algn="l">
-              <a:defRPr sz="1400" b="0">
-                <a:solidFill>
-                  <a:srgbClr val="CCCCDD"/>
-                </a:solidFill>
-                <a:latin typeface="Calibri"/>
-              </a:defRPr>
+              <a:spcBef>
+                <a:spcPts val="0"/>
+              </a:spcBef>
+              <a:spcAft>
+                <a:spcPts val="0"/>
+              </a:spcAft>
             </a:pPr>
             <a:r>
-              <a:t>Aerospace</a:t>
-            </a:r>
-          </a:p>
-        </p:txBody>
-      </p:sp>
-      <p:sp>
-        <p:nvSpPr>
-          <p:cNvPr id="4" name="Oval 3"/>
-          <p:cNvSpPr/>
-          <p:nvPr/>
-        </p:nvSpPr>
-        <p:spPr>
-          <a:xfrm>
-            <a:off x="2743200" y="91440"/>
-            <a:ext cx="411480" cy="411480"/>
-          </a:xfrm>
-          <a:prstGeom prst="ellipse">
-            <a:avLst/>
-          </a:prstGeom>
-          <a:solidFill>
-            <a:srgbClr val="FF6B00"/>
-          </a:solidFill>
-          <a:ln>
-            <a:noFill/>
-          </a:ln>
-        </p:spPr>
-        <p:style>
-          <a:lnRef idx="1">
-            <a:schemeClr val="accent1"/>
-          </a:lnRef>
-          <a:fillRef idx="3">
-            <a:schemeClr val="accent1"/>
-          </a:fillRef>
-          <a:effectRef idx="2">
-            <a:schemeClr val="accent1"/>
-          </a:effectRef>
-          <a:fontRef idx="minor">
-            <a:schemeClr val="lt1"/>
-          </a:fontRef>
-        </p:style>
-        <p:txBody>
-          <a:bodyPr rtlCol="0" anchor="ctr"/>
-          <a:lstStyle/>
-          <a:p>
-            <a:pPr algn="ctr"/>
+              <a:rPr sz="1406" b="1">
+                <a:solidFill>
+                  <a:srgbClr val="EE6E1E"/>
+                </a:solidFill>
+                <a:latin typeface="DejaVu Sans"/>
+              </a:rPr>
+              <a:t>CNS AI Day 2026</a:t>
+            </a:r>
           </a:p>
         </p:txBody>
       </p:sp>
@@ -3219,8 +3213,8 @@
         </p:nvSpPr>
         <p:spPr>
           <a:xfrm>
-            <a:off x="3200400" y="45720"/>
-            <a:ext cx="6400800" cy="457200"/>
+            <a:off x="1229439" y="705445"/>
+            <a:ext cx="11457146" cy="982265"/>
           </a:xfrm>
           <a:prstGeom prst="rect">
             <a:avLst/>
@@ -3228,20 +3222,26 @@
           <a:noFill/>
         </p:spPr>
         <p:txBody>
-          <a:bodyPr wrap="square" anchor="t">
+          <a:bodyPr wrap="none" anchor="t" lIns="0" rIns="0" tIns="0" bIns="0">
             <a:spAutoFit/>
           </a:bodyPr>
           <a:lstStyle/>
           <a:p>
-            <a:pPr algn="l">
-              <a:defRPr sz="2600" b="1">
-                <a:solidFill>
-                  <a:srgbClr val="FF6B00"/>
-                </a:solidFill>
-                <a:latin typeface="Calibri"/>
-              </a:defRPr>
+            <a:pPr algn="ctr">
+              <a:spcBef>
+                <a:spcPts val="0"/>
+              </a:spcBef>
+              <a:spcAft>
+                <a:spcPts val="0"/>
+              </a:spcAft>
             </a:pPr>
             <a:r>
+              <a:rPr sz="3515" b="1">
+                <a:solidFill>
+                  <a:srgbClr val="F9FBFC"/>
+                </a:solidFill>
+                <a:latin typeface="DejaVu Sans"/>
+              </a:rPr>
               <a:t>COVERITY FINDINGS ANALYZER</a:t>
             </a:r>
           </a:p>
@@ -3255,8 +3255,8 @@
         </p:nvSpPr>
         <p:spPr>
           <a:xfrm>
-            <a:off x="2011680" y="502920"/>
-            <a:ext cx="8229600" cy="365760"/>
+            <a:off x="1470898" y="1321593"/>
+            <a:ext cx="10145553" cy="550068"/>
           </a:xfrm>
           <a:prstGeom prst="rect">
             <a:avLst/>
@@ -3264,20 +3264,26 @@
           <a:noFill/>
         </p:spPr>
         <p:txBody>
-          <a:bodyPr wrap="square" anchor="t">
+          <a:bodyPr wrap="none" anchor="t" lIns="0" rIns="0" tIns="0" bIns="0">
             <a:spAutoFit/>
           </a:bodyPr>
           <a:lstStyle/>
           <a:p>
             <a:pPr algn="ctr">
-              <a:defRPr sz="1400" b="0">
-                <a:solidFill>
-                  <a:srgbClr val="CCCCDD"/>
-                </a:solidFill>
-                <a:latin typeface="Calibri"/>
-              </a:defRPr>
+              <a:spcBef>
+                <a:spcPts val="0"/>
+              </a:spcBef>
+              <a:spcAft>
+                <a:spcPts val="0"/>
+              </a:spcAft>
             </a:pPr>
             <a:r>
+              <a:rPr sz="1968" b="0">
+                <a:solidFill>
+                  <a:srgbClr val="F9FBFC"/>
+                </a:solidFill>
+                <a:latin typeface="DejaVu Sans"/>
+              </a:rPr>
               <a:t>AI-Developed, Rule-Based Static Analysis for Aerospace</a:t>
             </a:r>
           </a:p>
@@ -3285,111 +3291,14 @@
       </p:sp>
       <p:sp>
         <p:nvSpPr>
-          <p:cNvPr id="7" name="Rounded Rectangle 6"/>
-          <p:cNvSpPr/>
-          <p:nvPr/>
-        </p:nvSpPr>
-        <p:spPr>
-          <a:xfrm>
-            <a:off x="9326880" y="73152"/>
-            <a:ext cx="2560320" cy="411480"/>
-          </a:xfrm>
-          <a:prstGeom prst="roundRect">
-            <a:avLst/>
-          </a:prstGeom>
-          <a:solidFill>
-            <a:srgbClr val="11182E"/>
-          </a:solidFill>
-          <a:ln w="19050">
-            <a:solidFill>
-              <a:srgbClr val="FF6B00"/>
-            </a:solidFill>
-          </a:ln>
-        </p:spPr>
-        <p:style>
-          <a:lnRef idx="1">
-            <a:schemeClr val="accent1"/>
-          </a:lnRef>
-          <a:fillRef idx="3">
-            <a:schemeClr val="accent1"/>
-          </a:fillRef>
-          <a:effectRef idx="2">
-            <a:schemeClr val="accent1"/>
-          </a:effectRef>
-          <a:fontRef idx="minor">
-            <a:schemeClr val="lt1"/>
-          </a:fontRef>
-        </p:style>
-        <p:txBody>
-          <a:bodyPr rtlCol="0" anchor="ctr"/>
-          <a:lstStyle/>
-          <a:p>
-            <a:pPr algn="ctr">
-              <a:defRPr sz="1300" b="1">
-                <a:solidFill>
-                  <a:srgbClr val="FF6B00"/>
-                </a:solidFill>
-              </a:defRPr>
-            </a:pPr>
-            <a:r>
-              <a:t>CNS AI Day 2026</a:t>
-            </a:r>
-          </a:p>
-        </p:txBody>
-      </p:sp>
-      <p:sp>
-        <p:nvSpPr>
-          <p:cNvPr id="8" name="Rectangle 7"/>
-          <p:cNvSpPr/>
-          <p:nvPr/>
-        </p:nvSpPr>
-        <p:spPr>
-          <a:xfrm>
-            <a:off x="274320" y="868680"/>
-            <a:ext cx="11612880" cy="18288"/>
-          </a:xfrm>
-          <a:prstGeom prst="rect">
-            <a:avLst/>
-          </a:prstGeom>
-          <a:solidFill>
-            <a:srgbClr val="FF6B00"/>
-          </a:solidFill>
-          <a:ln>
-            <a:noFill/>
-          </a:ln>
-        </p:spPr>
-        <p:style>
-          <a:lnRef idx="1">
-            <a:schemeClr val="accent1"/>
-          </a:lnRef>
-          <a:fillRef idx="3">
-            <a:schemeClr val="accent1"/>
-          </a:fillRef>
-          <a:effectRef idx="2">
-            <a:schemeClr val="accent1"/>
-          </a:effectRef>
-          <a:fontRef idx="minor">
-            <a:schemeClr val="lt1"/>
-          </a:fontRef>
-        </p:style>
-        <p:txBody>
-          <a:bodyPr rtlCol="0" anchor="ctr"/>
-          <a:lstStyle/>
-          <a:p>
-            <a:pPr algn="ctr"/>
-          </a:p>
-        </p:txBody>
-      </p:sp>
-      <p:sp>
-        <p:nvSpPr>
-          <p:cNvPr id="9" name="TextBox 8"/>
+          <p:cNvPr id="7" name="TextBox 6"/>
           <p:cNvSpPr txBox="1"/>
           <p:nvPr/>
         </p:nvSpPr>
         <p:spPr>
           <a:xfrm>
-            <a:off x="365760" y="1051560"/>
-            <a:ext cx="3657600" cy="320040"/>
+            <a:off x="838200" y="1973460"/>
+            <a:ext cx="3067050" cy="510778"/>
           </a:xfrm>
           <a:prstGeom prst="rect">
             <a:avLst/>
@@ -3397,35 +3306,41 @@
           <a:noFill/>
         </p:spPr>
         <p:txBody>
-          <a:bodyPr wrap="square" anchor="t">
+          <a:bodyPr wrap="none" anchor="t" lIns="0" rIns="0" tIns="0" bIns="0">
             <a:spAutoFit/>
           </a:bodyPr>
           <a:lstStyle/>
           <a:p>
             <a:pPr algn="l">
-              <a:defRPr sz="1600" b="1">
-                <a:solidFill>
-                  <a:srgbClr val="FF6B00"/>
-                </a:solidFill>
-                <a:latin typeface="Calibri"/>
-              </a:defRPr>
+              <a:spcBef>
+                <a:spcPts val="0"/>
+              </a:spcBef>
+              <a:spcAft>
+                <a:spcPts val="0"/>
+              </a:spcAft>
             </a:pPr>
             <a:r>
-              <a:t>  CORE FEATURES</a:t>
-            </a:r>
-          </a:p>
-        </p:txBody>
-      </p:sp>
-      <p:sp>
-        <p:nvSpPr>
-          <p:cNvPr id="10" name="TextBox 9"/>
+              <a:rPr sz="1828" b="1">
+                <a:solidFill>
+                  <a:srgbClr val="EE6E1E"/>
+                </a:solidFill>
+                <a:latin typeface="DejaVu Sans"/>
+              </a:rPr>
+              <a:t>CORE FEATURES</a:t>
+            </a:r>
+          </a:p>
+        </p:txBody>
+      </p:sp>
+      <p:sp>
+        <p:nvSpPr>
+          <p:cNvPr id="8" name="TextBox 7"/>
           <p:cNvSpPr txBox="1"/>
           <p:nvPr/>
         </p:nvSpPr>
         <p:spPr>
           <a:xfrm>
-            <a:off x="457200" y="1417320"/>
-            <a:ext cx="3474720" cy="201168"/>
+            <a:off x="742950" y="2375296"/>
+            <a:ext cx="3200400" cy="392906"/>
           </a:xfrm>
           <a:prstGeom prst="rect">
             <a:avLst/>
@@ -3433,20 +3348,26 @@
           <a:noFill/>
         </p:spPr>
         <p:txBody>
-          <a:bodyPr wrap="square" anchor="t">
+          <a:bodyPr wrap="none" anchor="t" lIns="0" rIns="0" tIns="0" bIns="0">
             <a:spAutoFit/>
           </a:bodyPr>
           <a:lstStyle/>
           <a:p>
             <a:pPr algn="l">
-              <a:defRPr sz="1100" b="1">
-                <a:solidFill>
-                  <a:srgbClr val="FFFFFF"/>
-                </a:solidFill>
-                <a:latin typeface="Calibri"/>
-              </a:defRPr>
+              <a:spcBef>
+                <a:spcPts val="0"/>
+              </a:spcBef>
+              <a:spcAft>
+                <a:spcPts val="0"/>
+              </a:spcAft>
             </a:pPr>
             <a:r>
+              <a:rPr sz="1406" b="1">
+                <a:solidFill>
+                  <a:srgbClr val="F9FBFC"/>
+                </a:solidFill>
+                <a:latin typeface="DejaVu Sans"/>
+              </a:rPr>
               <a:t>Aerospace Compliance</a:t>
             </a:r>
           </a:p>
@@ -3454,14 +3375,14 @@
       </p:sp>
       <p:sp>
         <p:nvSpPr>
-          <p:cNvPr id="11" name="TextBox 10"/>
+          <p:cNvPr id="9" name="TextBox 8"/>
           <p:cNvSpPr txBox="1"/>
           <p:nvPr/>
         </p:nvSpPr>
         <p:spPr>
           <a:xfrm>
-            <a:off x="457200" y="1600200"/>
-            <a:ext cx="3474720" cy="201168"/>
+            <a:off x="752475" y="2598539"/>
+            <a:ext cx="3181350" cy="412551"/>
           </a:xfrm>
           <a:prstGeom prst="rect">
             <a:avLst/>
@@ -3469,35 +3390,41 @@
           <a:noFill/>
         </p:spPr>
         <p:txBody>
-          <a:bodyPr wrap="square" anchor="t">
+          <a:bodyPr wrap="none" anchor="t" lIns="0" rIns="0" tIns="0" bIns="0">
             <a:spAutoFit/>
           </a:bodyPr>
           <a:lstStyle/>
           <a:p>
             <a:pPr algn="l">
-              <a:defRPr sz="1000" b="0">
-                <a:solidFill>
-                  <a:srgbClr val="CCCCDD"/>
-                </a:solidFill>
-                <a:latin typeface="Calibri"/>
-              </a:defRPr>
+              <a:spcBef>
+                <a:spcPts val="0"/>
+              </a:spcBef>
+              <a:spcAft>
+                <a:spcPts val="0"/>
+              </a:spcAft>
             </a:pPr>
             <a:r>
-              <a:t>  DO-178C, MISRA, CERT</a:t>
-            </a:r>
-          </a:p>
-        </p:txBody>
-      </p:sp>
-      <p:sp>
-        <p:nvSpPr>
-          <p:cNvPr id="12" name="TextBox 11"/>
+              <a:rPr sz="1476" b="0">
+                <a:solidFill>
+                  <a:srgbClr val="F9FBFC"/>
+                </a:solidFill>
+                <a:latin typeface="DejaVu Sans"/>
+              </a:rPr>
+              <a:t>- DO-178C, MISRA, CERT</a:t>
+            </a:r>
+          </a:p>
+        </p:txBody>
+      </p:sp>
+      <p:sp>
+        <p:nvSpPr>
+          <p:cNvPr id="10" name="TextBox 9"/>
           <p:cNvSpPr txBox="1"/>
           <p:nvPr/>
         </p:nvSpPr>
         <p:spPr>
           <a:xfrm>
-            <a:off x="457200" y="1965960"/>
-            <a:ext cx="3474720" cy="201168"/>
+            <a:off x="761999" y="2991445"/>
+            <a:ext cx="3086100" cy="373260"/>
           </a:xfrm>
           <a:prstGeom prst="rect">
             <a:avLst/>
@@ -3505,20 +3432,26 @@
           <a:noFill/>
         </p:spPr>
         <p:txBody>
-          <a:bodyPr wrap="square" anchor="t">
+          <a:bodyPr wrap="none" anchor="t" lIns="0" rIns="0" tIns="0" bIns="0">
             <a:spAutoFit/>
           </a:bodyPr>
           <a:lstStyle/>
           <a:p>
             <a:pPr algn="l">
-              <a:defRPr sz="1100" b="1">
-                <a:solidFill>
-                  <a:srgbClr val="FFFFFF"/>
-                </a:solidFill>
-                <a:latin typeface="Calibri"/>
-              </a:defRPr>
+              <a:spcBef>
+                <a:spcPts val="0"/>
+              </a:spcBef>
+              <a:spcAft>
+                <a:spcPts val="0"/>
+              </a:spcAft>
             </a:pPr>
             <a:r>
+              <a:rPr sz="1335" b="1">
+                <a:solidFill>
+                  <a:srgbClr val="F9FBFC"/>
+                </a:solidFill>
+                <a:latin typeface="DejaVu Sans"/>
+              </a:rPr>
               <a:t>100% Secure &amp; Offline</a:t>
             </a:r>
           </a:p>
@@ -3526,14 +3459,14 @@
       </p:sp>
       <p:sp>
         <p:nvSpPr>
-          <p:cNvPr id="13" name="TextBox 12"/>
+          <p:cNvPr id="11" name="TextBox 10"/>
           <p:cNvSpPr txBox="1"/>
           <p:nvPr/>
         </p:nvSpPr>
         <p:spPr>
           <a:xfrm>
-            <a:off x="457200" y="2148840"/>
-            <a:ext cx="3474720" cy="201168"/>
+            <a:off x="752475" y="3250406"/>
+            <a:ext cx="3581400" cy="373260"/>
           </a:xfrm>
           <a:prstGeom prst="rect">
             <a:avLst/>
@@ -3541,35 +3474,41 @@
           <a:noFill/>
         </p:spPr>
         <p:txBody>
-          <a:bodyPr wrap="square" anchor="t">
+          <a:bodyPr wrap="none" anchor="t" lIns="0" rIns="0" tIns="0" bIns="0">
             <a:spAutoFit/>
           </a:bodyPr>
           <a:lstStyle/>
           <a:p>
             <a:pPr algn="l">
-              <a:defRPr sz="1000" b="0">
-                <a:solidFill>
-                  <a:srgbClr val="CCCCDD"/>
-                </a:solidFill>
-                <a:latin typeface="Calibri"/>
-              </a:defRPr>
+              <a:spcBef>
+                <a:spcPts val="0"/>
+              </a:spcBef>
+              <a:spcAft>
+                <a:spcPts val="0"/>
+              </a:spcAft>
             </a:pPr>
             <a:r>
-              <a:t>  Source never leaves machine</a:t>
-            </a:r>
-          </a:p>
-        </p:txBody>
-      </p:sp>
-      <p:sp>
-        <p:nvSpPr>
-          <p:cNvPr id="14" name="TextBox 13"/>
+              <a:rPr sz="1335" b="0">
+                <a:solidFill>
+                  <a:srgbClr val="F9FBFC"/>
+                </a:solidFill>
+                <a:latin typeface="DejaVu Sans"/>
+              </a:rPr>
+              <a:t>- Source never leaves machine</a:t>
+            </a:r>
+          </a:p>
+        </p:txBody>
+      </p:sp>
+      <p:sp>
+        <p:nvSpPr>
+          <p:cNvPr id="12" name="TextBox 11"/>
           <p:cNvSpPr txBox="1"/>
           <p:nvPr/>
         </p:nvSpPr>
         <p:spPr>
           <a:xfrm>
-            <a:off x="457200" y="2514600"/>
-            <a:ext cx="3474720" cy="201168"/>
+            <a:off x="761999" y="3580804"/>
+            <a:ext cx="3133724" cy="373260"/>
           </a:xfrm>
           <a:prstGeom prst="rect">
             <a:avLst/>
@@ -3577,20 +3516,26 @@
           <a:noFill/>
         </p:spPr>
         <p:txBody>
-          <a:bodyPr wrap="square" anchor="t">
+          <a:bodyPr wrap="none" anchor="t" lIns="0" rIns="0" tIns="0" bIns="0">
             <a:spAutoFit/>
           </a:bodyPr>
           <a:lstStyle/>
           <a:p>
             <a:pPr algn="l">
-              <a:defRPr sz="1100" b="1">
-                <a:solidFill>
-                  <a:srgbClr val="FFFFFF"/>
-                </a:solidFill>
-                <a:latin typeface="Calibri"/>
-              </a:defRPr>
+              <a:spcBef>
+                <a:spcPts val="0"/>
+              </a:spcBef>
+              <a:spcAft>
+                <a:spcPts val="0"/>
+              </a:spcAft>
             </a:pPr>
             <a:r>
+              <a:rPr sz="1335" b="1">
+                <a:solidFill>
+                  <a:srgbClr val="F9FBFC"/>
+                </a:solidFill>
+                <a:latin typeface="DejaVu Sans"/>
+              </a:rPr>
               <a:t>No AI Tokens Required</a:t>
             </a:r>
           </a:p>
@@ -3598,14 +3543,14 @@
       </p:sp>
       <p:sp>
         <p:nvSpPr>
-          <p:cNvPr id="15" name="TextBox 14"/>
+          <p:cNvPr id="13" name="TextBox 12"/>
           <p:cNvSpPr txBox="1"/>
           <p:nvPr/>
         </p:nvSpPr>
         <p:spPr>
           <a:xfrm>
-            <a:off x="457200" y="2697480"/>
-            <a:ext cx="3474720" cy="201168"/>
+            <a:off x="752475" y="3848695"/>
+            <a:ext cx="2581275" cy="373260"/>
           </a:xfrm>
           <a:prstGeom prst="rect">
             <a:avLst/>
@@ -3613,35 +3558,41 @@
           <a:noFill/>
         </p:spPr>
         <p:txBody>
-          <a:bodyPr wrap="square" anchor="t">
+          <a:bodyPr wrap="none" anchor="t" lIns="0" rIns="0" tIns="0" bIns="0">
             <a:spAutoFit/>
           </a:bodyPr>
           <a:lstStyle/>
           <a:p>
             <a:pPr algn="l">
-              <a:defRPr sz="1000" b="0">
-                <a:solidFill>
-                  <a:srgbClr val="CCCCDD"/>
-                </a:solidFill>
-                <a:latin typeface="Calibri"/>
-              </a:defRPr>
+              <a:spcBef>
+                <a:spcPts val="0"/>
+              </a:spcBef>
+              <a:spcAft>
+                <a:spcPts val="0"/>
+              </a:spcAft>
             </a:pPr>
             <a:r>
-              <a:t>  Runs 100% offline</a:t>
-            </a:r>
-          </a:p>
-        </p:txBody>
-      </p:sp>
-      <p:sp>
-        <p:nvSpPr>
-          <p:cNvPr id="16" name="TextBox 15"/>
+              <a:rPr sz="1335" b="0">
+                <a:solidFill>
+                  <a:srgbClr val="F9FBFC"/>
+                </a:solidFill>
+                <a:latin typeface="DejaVu Sans"/>
+              </a:rPr>
+              <a:t>- Runs 100% offline</a:t>
+            </a:r>
+          </a:p>
+        </p:txBody>
+      </p:sp>
+      <p:sp>
+        <p:nvSpPr>
+          <p:cNvPr id="14" name="TextBox 13"/>
           <p:cNvSpPr txBox="1"/>
           <p:nvPr/>
         </p:nvSpPr>
         <p:spPr>
           <a:xfrm>
-            <a:off x="457200" y="3063240"/>
-            <a:ext cx="3474720" cy="201168"/>
+            <a:off x="761999" y="4179093"/>
+            <a:ext cx="3571875" cy="392906"/>
           </a:xfrm>
           <a:prstGeom prst="rect">
             <a:avLst/>
@@ -3649,20 +3600,26 @@
           <a:noFill/>
         </p:spPr>
         <p:txBody>
-          <a:bodyPr wrap="square" anchor="t">
+          <a:bodyPr wrap="none" anchor="t" lIns="0" rIns="0" tIns="0" bIns="0">
             <a:spAutoFit/>
           </a:bodyPr>
           <a:lstStyle/>
           <a:p>
             <a:pPr algn="l">
-              <a:defRPr sz="1100" b="1">
-                <a:solidFill>
-                  <a:srgbClr val="FFFFFF"/>
-                </a:solidFill>
-                <a:latin typeface="Calibri"/>
-              </a:defRPr>
+              <a:spcBef>
+                <a:spcPts val="0"/>
+              </a:spcBef>
+              <a:spcAft>
+                <a:spcPts val="0"/>
+              </a:spcAft>
             </a:pPr>
             <a:r>
+              <a:rPr sz="1406" b="1">
+                <a:solidFill>
+                  <a:srgbClr val="F9FBFC"/>
+                </a:solidFill>
+                <a:latin typeface="DejaVu Sans"/>
+              </a:rPr>
               <a:t>Reduces SME Dependency</a:t>
             </a:r>
           </a:p>
@@ -3670,14 +3627,14 @@
       </p:sp>
       <p:sp>
         <p:nvSpPr>
-          <p:cNvPr id="17" name="TextBox 16"/>
+          <p:cNvPr id="15" name="TextBox 14"/>
           <p:cNvSpPr txBox="1"/>
           <p:nvPr/>
         </p:nvSpPr>
         <p:spPr>
           <a:xfrm>
-            <a:off x="457200" y="3246120"/>
-            <a:ext cx="3474720" cy="201168"/>
+            <a:off x="752475" y="4402335"/>
+            <a:ext cx="2600325" cy="471487"/>
           </a:xfrm>
           <a:prstGeom prst="rect">
             <a:avLst/>
@@ -3685,35 +3642,41 @@
           <a:noFill/>
         </p:spPr>
         <p:txBody>
-          <a:bodyPr wrap="square" anchor="t">
+          <a:bodyPr wrap="none" anchor="t" lIns="0" rIns="0" tIns="0" bIns="0">
             <a:spAutoFit/>
           </a:bodyPr>
           <a:lstStyle/>
           <a:p>
             <a:pPr algn="l">
-              <a:defRPr sz="1000" b="0">
-                <a:solidFill>
-                  <a:srgbClr val="CCCCDD"/>
-                </a:solidFill>
-                <a:latin typeface="Calibri"/>
-              </a:defRPr>
+              <a:spcBef>
+                <a:spcPts val="0"/>
+              </a:spcBef>
+              <a:spcAft>
+                <a:spcPts val="0"/>
+              </a:spcAft>
             </a:pPr>
             <a:r>
-              <a:t>  80% reduction</a:t>
-            </a:r>
-          </a:p>
-        </p:txBody>
-      </p:sp>
-      <p:sp>
-        <p:nvSpPr>
-          <p:cNvPr id="18" name="TextBox 17"/>
+              <a:rPr sz="1687" b="0">
+                <a:solidFill>
+                  <a:srgbClr val="F9FBFC"/>
+                </a:solidFill>
+                <a:latin typeface="DejaVu Sans"/>
+              </a:rPr>
+              <a:t>- 80% reduction</a:t>
+            </a:r>
+          </a:p>
+        </p:txBody>
+      </p:sp>
+      <p:sp>
+        <p:nvSpPr>
+          <p:cNvPr id="16" name="TextBox 15"/>
           <p:cNvSpPr txBox="1"/>
           <p:nvPr/>
         </p:nvSpPr>
         <p:spPr>
           <a:xfrm>
-            <a:off x="4206240" y="1051560"/>
-            <a:ext cx="3200400" cy="320040"/>
+            <a:off x="4333875" y="1955601"/>
+            <a:ext cx="4248150" cy="510778"/>
           </a:xfrm>
           <a:prstGeom prst="rect">
             <a:avLst/>
@@ -3721,559 +3684,41 @@
           <a:noFill/>
         </p:spPr>
         <p:txBody>
-          <a:bodyPr wrap="square" anchor="t">
+          <a:bodyPr wrap="none" anchor="t" lIns="0" rIns="0" tIns="0" bIns="0">
             <a:spAutoFit/>
           </a:bodyPr>
           <a:lstStyle/>
           <a:p>
             <a:pPr algn="l">
-              <a:defRPr sz="1600" b="1">
-                <a:solidFill>
-                  <a:srgbClr val="FF6B00"/>
-                </a:solidFill>
-                <a:latin typeface="Calibri"/>
-              </a:defRPr>
+              <a:spcBef>
+                <a:spcPts val="0"/>
+              </a:spcBef>
+              <a:spcAft>
+                <a:spcPts val="0"/>
+              </a:spcAft>
             </a:pPr>
             <a:r>
-              <a:t>⚖  WORK DETAILS</a:t>
-            </a:r>
-          </a:p>
-        </p:txBody>
-      </p:sp>
-      <p:sp>
-        <p:nvSpPr>
-          <p:cNvPr id="19" name="Rounded Rectangle 18"/>
-          <p:cNvSpPr/>
-          <p:nvPr/>
-        </p:nvSpPr>
-        <p:spPr>
-          <a:xfrm>
-            <a:off x="4206240" y="1417320"/>
-            <a:ext cx="2103120" cy="384048"/>
-          </a:xfrm>
-          <a:prstGeom prst="roundRect">
-            <a:avLst/>
-          </a:prstGeom>
-          <a:solidFill>
-            <a:srgbClr val="3A1515"/>
-          </a:solidFill>
-          <a:ln w="12700">
-            <a:solidFill>
-              <a:srgbClr val="FF6B00"/>
-            </a:solidFill>
-          </a:ln>
-        </p:spPr>
-        <p:style>
-          <a:lnRef idx="1">
-            <a:schemeClr val="accent1"/>
-          </a:lnRef>
-          <a:fillRef idx="3">
-            <a:schemeClr val="accent1"/>
-          </a:fillRef>
-          <a:effectRef idx="2">
-            <a:schemeClr val="accent1"/>
-          </a:effectRef>
-          <a:fontRef idx="minor">
-            <a:schemeClr val="lt1"/>
-          </a:fontRef>
-        </p:style>
-        <p:txBody>
-          <a:bodyPr rtlCol="0" anchor="ctr"/>
-          <a:lstStyle/>
-          <a:p>
-            <a:pPr algn="ctr">
-              <a:defRPr sz="1100" b="1">
-                <a:solidFill>
-                  <a:srgbClr val="FF4444"/>
-                </a:solidFill>
-              </a:defRPr>
-            </a:pPr>
-            <a:r>
-              <a:t>MANUAL</a:t>
-            </a:r>
-          </a:p>
-        </p:txBody>
-      </p:sp>
-      <p:sp>
-        <p:nvSpPr>
-          <p:cNvPr id="20" name="Rounded Rectangle 19"/>
-          <p:cNvSpPr/>
-          <p:nvPr/>
-        </p:nvSpPr>
-        <p:spPr>
-          <a:xfrm>
-            <a:off x="6355079" y="1417320"/>
-            <a:ext cx="2103120" cy="384048"/>
-          </a:xfrm>
-          <a:prstGeom prst="roundRect">
-            <a:avLst/>
-          </a:prstGeom>
-          <a:solidFill>
-            <a:srgbClr val="0F2E1A"/>
-          </a:solidFill>
-          <a:ln w="12700">
-            <a:solidFill>
-              <a:srgbClr val="FF6B00"/>
-            </a:solidFill>
-          </a:ln>
-        </p:spPr>
-        <p:style>
-          <a:lnRef idx="1">
-            <a:schemeClr val="accent1"/>
-          </a:lnRef>
-          <a:fillRef idx="3">
-            <a:schemeClr val="accent1"/>
-          </a:fillRef>
-          <a:effectRef idx="2">
-            <a:schemeClr val="accent1"/>
-          </a:effectRef>
-          <a:fontRef idx="minor">
-            <a:schemeClr val="lt1"/>
-          </a:fontRef>
-        </p:style>
-        <p:txBody>
-          <a:bodyPr rtlCol="0" anchor="ctr"/>
-          <a:lstStyle/>
-          <a:p>
-            <a:pPr algn="ctr">
-              <a:defRPr sz="1100" b="1">
-                <a:solidFill>
-                  <a:srgbClr val="00CC66"/>
-                </a:solidFill>
-              </a:defRPr>
-            </a:pPr>
-            <a:r>
-              <a:t>WITH TOOL</a:t>
-            </a:r>
-          </a:p>
-        </p:txBody>
-      </p:sp>
-      <p:sp>
-        <p:nvSpPr>
-          <p:cNvPr id="21" name="Rounded Rectangle 20"/>
-          <p:cNvSpPr/>
-          <p:nvPr/>
-        </p:nvSpPr>
-        <p:spPr>
-          <a:xfrm>
-            <a:off x="4206240" y="1837943"/>
-            <a:ext cx="2103120" cy="384048"/>
-          </a:xfrm>
-          <a:prstGeom prst="roundRect">
-            <a:avLst/>
-          </a:prstGeom>
-          <a:solidFill>
-            <a:srgbClr val="3A1515"/>
-          </a:solidFill>
-          <a:ln>
-            <a:noFill/>
-          </a:ln>
-        </p:spPr>
-        <p:style>
-          <a:lnRef idx="1">
-            <a:schemeClr val="accent1"/>
-          </a:lnRef>
-          <a:fillRef idx="3">
-            <a:schemeClr val="accent1"/>
-          </a:fillRef>
-          <a:effectRef idx="2">
-            <a:schemeClr val="accent1"/>
-          </a:effectRef>
-          <a:fontRef idx="minor">
-            <a:schemeClr val="lt1"/>
-          </a:fontRef>
-        </p:style>
-        <p:txBody>
-          <a:bodyPr rtlCol="0" anchor="ctr" wrap="square"/>
-          <a:lstStyle/>
-          <a:p>
-            <a:pPr>
-              <a:defRPr sz="900">
-                <a:solidFill>
-                  <a:srgbClr val="CCCCDD"/>
-                </a:solidFill>
-              </a:defRPr>
-            </a:pPr>
-            <a:r>
-              <a:t>⏱ 10-15 min / defect</a:t>
-            </a:r>
-          </a:p>
-        </p:txBody>
-      </p:sp>
-      <p:sp>
-        <p:nvSpPr>
-          <p:cNvPr id="22" name="Rounded Rectangle 21"/>
-          <p:cNvSpPr/>
-          <p:nvPr/>
-        </p:nvSpPr>
-        <p:spPr>
-          <a:xfrm>
-            <a:off x="6355079" y="1837943"/>
-            <a:ext cx="2103120" cy="384048"/>
-          </a:xfrm>
-          <a:prstGeom prst="roundRect">
-            <a:avLst/>
-          </a:prstGeom>
-          <a:solidFill>
-            <a:srgbClr val="0F2E1A"/>
-          </a:solidFill>
-          <a:ln>
-            <a:noFill/>
-          </a:ln>
-        </p:spPr>
-        <p:style>
-          <a:lnRef idx="1">
-            <a:schemeClr val="accent1"/>
-          </a:lnRef>
-          <a:fillRef idx="3">
-            <a:schemeClr val="accent1"/>
-          </a:fillRef>
-          <a:effectRef idx="2">
-            <a:schemeClr val="accent1"/>
-          </a:effectRef>
-          <a:fontRef idx="minor">
-            <a:schemeClr val="lt1"/>
-          </a:fontRef>
-        </p:style>
-        <p:txBody>
-          <a:bodyPr rtlCol="0" anchor="ctr" wrap="square"/>
-          <a:lstStyle/>
-          <a:p>
-            <a:pPr>
-              <a:defRPr sz="900">
-                <a:solidFill>
-                  <a:srgbClr val="FFFFFF"/>
-                </a:solidFill>
-              </a:defRPr>
-            </a:pPr>
-            <a:r>
-              <a:t>⚡ 1-2 min / defect</a:t>
-            </a:r>
-          </a:p>
-        </p:txBody>
-      </p:sp>
-      <p:sp>
-        <p:nvSpPr>
-          <p:cNvPr id="23" name="Rounded Rectangle 22"/>
-          <p:cNvSpPr/>
-          <p:nvPr/>
-        </p:nvSpPr>
-        <p:spPr>
-          <a:xfrm>
-            <a:off x="4206240" y="2258568"/>
-            <a:ext cx="2103120" cy="384048"/>
-          </a:xfrm>
-          <a:prstGeom prst="roundRect">
-            <a:avLst/>
-          </a:prstGeom>
-          <a:solidFill>
-            <a:srgbClr val="3A1515"/>
-          </a:solidFill>
-          <a:ln>
-            <a:noFill/>
-          </a:ln>
-        </p:spPr>
-        <p:style>
-          <a:lnRef idx="1">
-            <a:schemeClr val="accent1"/>
-          </a:lnRef>
-          <a:fillRef idx="3">
-            <a:schemeClr val="accent1"/>
-          </a:fillRef>
-          <a:effectRef idx="2">
-            <a:schemeClr val="accent1"/>
-          </a:effectRef>
-          <a:fontRef idx="minor">
-            <a:schemeClr val="lt1"/>
-          </a:fontRef>
-        </p:style>
-        <p:txBody>
-          <a:bodyPr rtlCol="0" anchor="ctr" wrap="square"/>
-          <a:lstStyle/>
-          <a:p>
-            <a:pPr>
-              <a:defRPr sz="900">
-                <a:solidFill>
-                  <a:srgbClr val="CCCCDD"/>
-                </a:solidFill>
-              </a:defRPr>
-            </a:pPr>
-            <a:r>
-              <a:t>🔍 Source Code Investigation Required</a:t>
-            </a:r>
-          </a:p>
-        </p:txBody>
-      </p:sp>
-      <p:sp>
-        <p:nvSpPr>
-          <p:cNvPr id="24" name="Rounded Rectangle 23"/>
-          <p:cNvSpPr/>
-          <p:nvPr/>
-        </p:nvSpPr>
-        <p:spPr>
-          <a:xfrm>
-            <a:off x="6355079" y="2258568"/>
-            <a:ext cx="2103120" cy="384048"/>
-          </a:xfrm>
-          <a:prstGeom prst="roundRect">
-            <a:avLst/>
-          </a:prstGeom>
-          <a:solidFill>
-            <a:srgbClr val="0F2E1A"/>
-          </a:solidFill>
-          <a:ln>
-            <a:noFill/>
-          </a:ln>
-        </p:spPr>
-        <p:style>
-          <a:lnRef idx="1">
-            <a:schemeClr val="accent1"/>
-          </a:lnRef>
-          <a:fillRef idx="3">
-            <a:schemeClr val="accent1"/>
-          </a:fillRef>
-          <a:effectRef idx="2">
-            <a:schemeClr val="accent1"/>
-          </a:effectRef>
-          <a:fontRef idx="minor">
-            <a:schemeClr val="lt1"/>
-          </a:fontRef>
-        </p:style>
-        <p:txBody>
-          <a:bodyPr rtlCol="0" anchor="ctr" wrap="square"/>
-          <a:lstStyle/>
-          <a:p>
-            <a:pPr>
-              <a:defRPr sz="900">
-                <a:solidFill>
-                  <a:srgbClr val="FFFFFF"/>
-                </a:solidFill>
-              </a:defRPr>
-            </a:pPr>
-            <a:r>
-              <a:t>🤖 Automated Analysis</a:t>
-            </a:r>
-          </a:p>
-        </p:txBody>
-      </p:sp>
-      <p:sp>
-        <p:nvSpPr>
-          <p:cNvPr id="25" name="Rounded Rectangle 24"/>
-          <p:cNvSpPr/>
-          <p:nvPr/>
-        </p:nvSpPr>
-        <p:spPr>
-          <a:xfrm>
-            <a:off x="4206240" y="2679191"/>
-            <a:ext cx="2103120" cy="384048"/>
-          </a:xfrm>
-          <a:prstGeom prst="roundRect">
-            <a:avLst/>
-          </a:prstGeom>
-          <a:solidFill>
-            <a:srgbClr val="3A1515"/>
-          </a:solidFill>
-          <a:ln>
-            <a:noFill/>
-          </a:ln>
-        </p:spPr>
-        <p:style>
-          <a:lnRef idx="1">
-            <a:schemeClr val="accent1"/>
-          </a:lnRef>
-          <a:fillRef idx="3">
-            <a:schemeClr val="accent1"/>
-          </a:fillRef>
-          <a:effectRef idx="2">
-            <a:schemeClr val="accent1"/>
-          </a:effectRef>
-          <a:fontRef idx="minor">
-            <a:schemeClr val="lt1"/>
-          </a:fontRef>
-        </p:style>
-        <p:txBody>
-          <a:bodyPr rtlCol="0" anchor="ctr" wrap="square"/>
-          <a:lstStyle/>
-          <a:p>
-            <a:pPr>
-              <a:defRPr sz="900">
-                <a:solidFill>
-                  <a:srgbClr val="CCCCDD"/>
-                </a:solidFill>
-              </a:defRPr>
-            </a:pPr>
-            <a:r>
-              <a:t>🧠 Context Analysis Required</a:t>
-            </a:r>
-          </a:p>
-        </p:txBody>
-      </p:sp>
-      <p:sp>
-        <p:nvSpPr>
-          <p:cNvPr id="26" name="Rounded Rectangle 25"/>
-          <p:cNvSpPr/>
-          <p:nvPr/>
-        </p:nvSpPr>
-        <p:spPr>
-          <a:xfrm>
-            <a:off x="6355079" y="2679191"/>
-            <a:ext cx="2103120" cy="384048"/>
-          </a:xfrm>
-          <a:prstGeom prst="roundRect">
-            <a:avLst/>
-          </a:prstGeom>
-          <a:solidFill>
-            <a:srgbClr val="0F2E1A"/>
-          </a:solidFill>
-          <a:ln>
-            <a:noFill/>
-          </a:ln>
-        </p:spPr>
-        <p:style>
-          <a:lnRef idx="1">
-            <a:schemeClr val="accent1"/>
-          </a:lnRef>
-          <a:fillRef idx="3">
-            <a:schemeClr val="accent1"/>
-          </a:fillRef>
-          <a:effectRef idx="2">
-            <a:schemeClr val="accent1"/>
-          </a:effectRef>
-          <a:fontRef idx="minor">
-            <a:schemeClr val="lt1"/>
-          </a:fontRef>
-        </p:style>
-        <p:txBody>
-          <a:bodyPr rtlCol="0" anchor="ctr" wrap="square"/>
-          <a:lstStyle/>
-          <a:p>
-            <a:pPr>
-              <a:defRPr sz="900">
-                <a:solidFill>
-                  <a:srgbClr val="FFFFFF"/>
-                </a:solidFill>
-              </a:defRPr>
-            </a:pPr>
-            <a:r>
-              <a:t>✅ One Controlled Flow</a:t>
-            </a:r>
-          </a:p>
-        </p:txBody>
-      </p:sp>
-      <p:sp>
-        <p:nvSpPr>
-          <p:cNvPr id="27" name="Rounded Rectangle 26"/>
-          <p:cNvSpPr/>
-          <p:nvPr/>
-        </p:nvSpPr>
-        <p:spPr>
-          <a:xfrm>
-            <a:off x="4206240" y="3099815"/>
-            <a:ext cx="2103120" cy="384048"/>
-          </a:xfrm>
-          <a:prstGeom prst="roundRect">
-            <a:avLst/>
-          </a:prstGeom>
-          <a:solidFill>
-            <a:srgbClr val="3A1515"/>
-          </a:solidFill>
-          <a:ln>
-            <a:noFill/>
-          </a:ln>
-        </p:spPr>
-        <p:style>
-          <a:lnRef idx="1">
-            <a:schemeClr val="accent1"/>
-          </a:lnRef>
-          <a:fillRef idx="3">
-            <a:schemeClr val="accent1"/>
-          </a:fillRef>
-          <a:effectRef idx="2">
-            <a:schemeClr val="accent1"/>
-          </a:effectRef>
-          <a:fontRef idx="minor">
-            <a:schemeClr val="lt1"/>
-          </a:fontRef>
-        </p:style>
-        <p:txBody>
-          <a:bodyPr rtlCol="0" anchor="ctr" wrap="square"/>
-          <a:lstStyle/>
-          <a:p>
-            <a:pPr>
-              <a:defRPr sz="900">
-                <a:solidFill>
-                  <a:srgbClr val="CCCCDD"/>
-                </a:solidFill>
-              </a:defRPr>
-            </a:pPr>
-            <a:r>
-              <a:t>📝 Disposition &amp; Documentation Required</a:t>
-            </a:r>
-          </a:p>
-        </p:txBody>
-      </p:sp>
-      <p:sp>
-        <p:nvSpPr>
-          <p:cNvPr id="28" name="Rounded Rectangle 27"/>
-          <p:cNvSpPr/>
-          <p:nvPr/>
-        </p:nvSpPr>
-        <p:spPr>
-          <a:xfrm>
-            <a:off x="6355079" y="3099815"/>
-            <a:ext cx="2103120" cy="384048"/>
-          </a:xfrm>
-          <a:prstGeom prst="roundRect">
-            <a:avLst/>
-          </a:prstGeom>
-          <a:solidFill>
-            <a:srgbClr val="0F2E1A"/>
-          </a:solidFill>
-          <a:ln>
-            <a:noFill/>
-          </a:ln>
-        </p:spPr>
-        <p:style>
-          <a:lnRef idx="1">
-            <a:schemeClr val="accent1"/>
-          </a:lnRef>
-          <a:fillRef idx="3">
-            <a:schemeClr val="accent1"/>
-          </a:fillRef>
-          <a:effectRef idx="2">
-            <a:schemeClr val="accent1"/>
-          </a:effectRef>
-          <a:fontRef idx="minor">
-            <a:schemeClr val="lt1"/>
-          </a:fontRef>
-        </p:style>
-        <p:txBody>
-          <a:bodyPr rtlCol="0" anchor="ctr" wrap="square"/>
-          <a:lstStyle/>
-          <a:p>
-            <a:pPr>
-              <a:defRPr sz="900">
-                <a:solidFill>
-                  <a:srgbClr val="FFFFFF"/>
-                </a:solidFill>
-              </a:defRPr>
-            </a:pPr>
-            <a:r>
-              <a:t>📊 Higher Quality</a:t>
-            </a:r>
-          </a:p>
-        </p:txBody>
-      </p:sp>
-      <p:sp>
-        <p:nvSpPr>
-          <p:cNvPr id="29" name="TextBox 28"/>
+              <a:rPr sz="1828" b="1">
+                <a:solidFill>
+                  <a:srgbClr val="EE6E1E"/>
+                </a:solidFill>
+                <a:latin typeface="DejaVu Sans"/>
+              </a:rPr>
+              <a:t>MANUAL vs AUTOMATED</a:t>
+            </a:r>
+          </a:p>
+        </p:txBody>
+      </p:sp>
+      <p:sp>
+        <p:nvSpPr>
+          <p:cNvPr id="17" name="TextBox 16"/>
           <p:cNvSpPr txBox="1"/>
           <p:nvPr/>
         </p:nvSpPr>
         <p:spPr>
           <a:xfrm>
-            <a:off x="4480559" y="3593591"/>
-            <a:ext cx="2286000" cy="457200"/>
+            <a:off x="4124324" y="2419945"/>
+            <a:ext cx="2286000" cy="353615"/>
           </a:xfrm>
           <a:prstGeom prst="rect">
             <a:avLst/>
@@ -4281,35 +3726,41 @@
           <a:noFill/>
         </p:spPr>
         <p:txBody>
-          <a:bodyPr wrap="square" anchor="t">
+          <a:bodyPr wrap="none" anchor="t" lIns="0" rIns="0" tIns="0" bIns="0">
             <a:spAutoFit/>
           </a:bodyPr>
           <a:lstStyle/>
           <a:p>
             <a:pPr algn="l">
-              <a:defRPr sz="2800" b="1">
-                <a:solidFill>
-                  <a:srgbClr val="FF6B00"/>
-                </a:solidFill>
-                <a:latin typeface="Calibri"/>
-              </a:defRPr>
+              <a:spcBef>
+                <a:spcPts val="0"/>
+              </a:spcBef>
+              <a:spcAft>
+                <a:spcPts val="0"/>
+              </a:spcAft>
             </a:pPr>
             <a:r>
-              <a:t>~90%</a:t>
-            </a:r>
-          </a:p>
-        </p:txBody>
-      </p:sp>
-      <p:sp>
-        <p:nvSpPr>
-          <p:cNvPr id="30" name="TextBox 29"/>
+              <a:rPr sz="1265" b="1">
+                <a:solidFill>
+                  <a:srgbClr val="F9FBFC"/>
+                </a:solidFill>
+                <a:latin typeface="DejaVu Sans"/>
+              </a:rPr>
+              <a:t>MANUAL PROCESS</a:t>
+            </a:r>
+          </a:p>
+        </p:txBody>
+      </p:sp>
+      <p:sp>
+        <p:nvSpPr>
+          <p:cNvPr id="18" name="TextBox 17"/>
           <p:cNvSpPr txBox="1"/>
           <p:nvPr/>
         </p:nvSpPr>
         <p:spPr>
           <a:xfrm>
-            <a:off x="4480559" y="3941063"/>
-            <a:ext cx="2286000" cy="274320"/>
+            <a:off x="6448425" y="2509242"/>
+            <a:ext cx="2609850" cy="353615"/>
           </a:xfrm>
           <a:prstGeom prst="rect">
             <a:avLst/>
@@ -4317,35 +3768,41 @@
           <a:noFill/>
         </p:spPr>
         <p:txBody>
-          <a:bodyPr wrap="square" anchor="t">
+          <a:bodyPr wrap="none" anchor="t" lIns="0" rIns="0" tIns="0" bIns="0">
             <a:spAutoFit/>
           </a:bodyPr>
           <a:lstStyle/>
           <a:p>
             <a:pPr algn="l">
-              <a:defRPr sz="1100" b="0">
-                <a:solidFill>
-                  <a:srgbClr val="CCCCDD"/>
-                </a:solidFill>
-                <a:latin typeface="Calibri"/>
-              </a:defRPr>
+              <a:spcBef>
+                <a:spcPts val="0"/>
+              </a:spcBef>
+              <a:spcAft>
+                <a:spcPts val="0"/>
+              </a:spcAft>
             </a:pPr>
             <a:r>
-              <a:t>Time Reduction</a:t>
-            </a:r>
-          </a:p>
-        </p:txBody>
-      </p:sp>
-      <p:sp>
-        <p:nvSpPr>
-          <p:cNvPr id="31" name="TextBox 30"/>
+              <a:rPr sz="1265" b="1">
+                <a:solidFill>
+                  <a:srgbClr val="F9FBFC"/>
+                </a:solidFill>
+                <a:latin typeface="DejaVu Sans"/>
+              </a:rPr>
+              <a:t>AUTOMATED PROCESS</a:t>
+            </a:r>
+          </a:p>
+        </p:txBody>
+      </p:sp>
+      <p:sp>
+        <p:nvSpPr>
+          <p:cNvPr id="19" name="TextBox 18"/>
           <p:cNvSpPr txBox="1"/>
           <p:nvPr/>
         </p:nvSpPr>
         <p:spPr>
           <a:xfrm>
-            <a:off x="365760" y="4434840"/>
-            <a:ext cx="4114800" cy="320040"/>
+            <a:off x="4086225" y="2759273"/>
+            <a:ext cx="2581275" cy="314325"/>
           </a:xfrm>
           <a:prstGeom prst="rect">
             <a:avLst/>
@@ -4353,35 +3810,41 @@
           <a:noFill/>
         </p:spPr>
         <p:txBody>
-          <a:bodyPr wrap="square" anchor="t">
+          <a:bodyPr wrap="none" anchor="t" lIns="0" rIns="0" tIns="0" bIns="0">
             <a:spAutoFit/>
           </a:bodyPr>
           <a:lstStyle/>
           <a:p>
             <a:pPr algn="l">
-              <a:defRPr sz="1400" b="1">
-                <a:solidFill>
-                  <a:srgbClr val="FF6B00"/>
-                </a:solidFill>
-                <a:latin typeface="Calibri"/>
-              </a:defRPr>
+              <a:spcBef>
+                <a:spcPts val="0"/>
+              </a:spcBef>
+              <a:spcAft>
+                <a:spcPts val="0"/>
+              </a:spcAft>
             </a:pPr>
             <a:r>
-              <a:t>💰  COST SAVINGS PER PROGRAM</a:t>
-            </a:r>
-          </a:p>
-        </p:txBody>
-      </p:sp>
-      <p:sp>
-        <p:nvSpPr>
-          <p:cNvPr id="32" name="TextBox 31"/>
+              <a:rPr sz="1125" b="0">
+                <a:solidFill>
+                  <a:srgbClr val="F9FBFC"/>
+                </a:solidFill>
+                <a:latin typeface="DejaVu Sans"/>
+              </a:rPr>
+              <a:t>10-15 minutes per defect</a:t>
+            </a:r>
+          </a:p>
+        </p:txBody>
+      </p:sp>
+      <p:sp>
+        <p:nvSpPr>
+          <p:cNvPr id="20" name="TextBox 19"/>
           <p:cNvSpPr txBox="1"/>
           <p:nvPr/>
         </p:nvSpPr>
         <p:spPr>
           <a:xfrm>
-            <a:off x="457200" y="4754879"/>
-            <a:ext cx="5943600" cy="256032"/>
+            <a:off x="4076699" y="3053953"/>
+            <a:ext cx="1714500" cy="314325"/>
           </a:xfrm>
           <a:prstGeom prst="rect">
             <a:avLst/>
@@ -4389,35 +3852,41 @@
           <a:noFill/>
         </p:spPr>
         <p:txBody>
-          <a:bodyPr wrap="square" anchor="t">
+          <a:bodyPr wrap="none" anchor="t" lIns="0" rIns="0" tIns="0" bIns="0">
             <a:spAutoFit/>
           </a:bodyPr>
           <a:lstStyle/>
           <a:p>
             <a:pPr algn="l">
-              <a:defRPr sz="1200" b="0">
-                <a:solidFill>
-                  <a:srgbClr val="FFFFFF"/>
-                </a:solidFill>
-                <a:latin typeface="Calibri"/>
-              </a:defRPr>
+              <a:spcBef>
+                <a:spcPts val="0"/>
+              </a:spcBef>
+              <a:spcAft>
+                <a:spcPts val="0"/>
+              </a:spcAft>
             </a:pPr>
             <a:r>
-              <a:t>RL1 (1,000 defects): 250 hrs → 33 hrs = </a:t>
-            </a:r>
-          </a:p>
-        </p:txBody>
-      </p:sp>
-      <p:sp>
-        <p:nvSpPr>
-          <p:cNvPr id="33" name="TextBox 32"/>
+              <a:rPr sz="1125" b="0">
+                <a:solidFill>
+                  <a:srgbClr val="F9FBFC"/>
+                </a:solidFill>
+                <a:latin typeface="DejaVu Sans"/>
+              </a:rPr>
+              <a:t>Source Code</a:t>
+            </a:r>
+          </a:p>
+        </p:txBody>
+      </p:sp>
+      <p:sp>
+        <p:nvSpPr>
+          <p:cNvPr id="21" name="TextBox 20"/>
           <p:cNvSpPr txBox="1"/>
           <p:nvPr/>
         </p:nvSpPr>
         <p:spPr>
           <a:xfrm>
-            <a:off x="4572000" y="4754879"/>
-            <a:ext cx="2743200" cy="256032"/>
+            <a:off x="4086225" y="3250406"/>
+            <a:ext cx="2381250" cy="314325"/>
           </a:xfrm>
           <a:prstGeom prst="rect">
             <a:avLst/>
@@ -4425,35 +3894,41 @@
           <a:noFill/>
         </p:spPr>
         <p:txBody>
-          <a:bodyPr wrap="square" anchor="t">
+          <a:bodyPr wrap="none" anchor="t" lIns="0" rIns="0" tIns="0" bIns="0">
             <a:spAutoFit/>
           </a:bodyPr>
           <a:lstStyle/>
           <a:p>
             <a:pPr algn="l">
-              <a:defRPr sz="1200" b="1">
-                <a:solidFill>
-                  <a:srgbClr val="FF6B00"/>
-                </a:solidFill>
-                <a:latin typeface="Calibri"/>
-              </a:defRPr>
+              <a:spcBef>
+                <a:spcPts val="0"/>
+              </a:spcBef>
+              <a:spcAft>
+                <a:spcPts val="0"/>
+              </a:spcAft>
             </a:pPr>
             <a:r>
-              <a:t>217 hrs SAVED</a:t>
-            </a:r>
-          </a:p>
-        </p:txBody>
-      </p:sp>
-      <p:sp>
-        <p:nvSpPr>
-          <p:cNvPr id="34" name="TextBox 33"/>
+              <a:rPr sz="1125" b="0">
+                <a:solidFill>
+                  <a:srgbClr val="F9FBFC"/>
+                </a:solidFill>
+                <a:latin typeface="DejaVu Sans"/>
+              </a:rPr>
+              <a:t>Investigation Required</a:t>
+            </a:r>
+          </a:p>
+        </p:txBody>
+      </p:sp>
+      <p:sp>
+        <p:nvSpPr>
+          <p:cNvPr id="22" name="TextBox 21"/>
           <p:cNvSpPr txBox="1"/>
           <p:nvPr/>
         </p:nvSpPr>
         <p:spPr>
           <a:xfrm>
-            <a:off x="457200" y="5029199"/>
-            <a:ext cx="5943600" cy="256032"/>
+            <a:off x="4086225" y="3607593"/>
+            <a:ext cx="2628900" cy="314325"/>
           </a:xfrm>
           <a:prstGeom prst="rect">
             <a:avLst/>
@@ -4461,35 +3936,41 @@
           <a:noFill/>
         </p:spPr>
         <p:txBody>
-          <a:bodyPr wrap="square" anchor="t">
+          <a:bodyPr wrap="none" anchor="t" lIns="0" rIns="0" tIns="0" bIns="0">
             <a:spAutoFit/>
           </a:bodyPr>
           <a:lstStyle/>
           <a:p>
             <a:pPr algn="l">
-              <a:defRPr sz="1200" b="0">
-                <a:solidFill>
-                  <a:srgbClr val="FFFFFF"/>
-                </a:solidFill>
-                <a:latin typeface="Calibri"/>
-              </a:defRPr>
+              <a:spcBef>
+                <a:spcPts val="0"/>
+              </a:spcBef>
+              <a:spcAft>
+                <a:spcPts val="0"/>
+              </a:spcAft>
             </a:pPr>
             <a:r>
-              <a:t>Program (4,000 defects): 1,000 hrs → 133 hrs = </a:t>
-            </a:r>
-          </a:p>
-        </p:txBody>
-      </p:sp>
-      <p:sp>
-        <p:nvSpPr>
-          <p:cNvPr id="35" name="TextBox 34"/>
+              <a:rPr sz="1125" b="0">
+                <a:solidFill>
+                  <a:srgbClr val="F9FBFC"/>
+                </a:solidFill>
+                <a:latin typeface="DejaVu Sans"/>
+              </a:rPr>
+              <a:t>Context Analysis Required</a:t>
+            </a:r>
+          </a:p>
+        </p:txBody>
+      </p:sp>
+      <p:sp>
+        <p:nvSpPr>
+          <p:cNvPr id="23" name="TextBox 22"/>
           <p:cNvSpPr txBox="1"/>
           <p:nvPr/>
         </p:nvSpPr>
         <p:spPr>
           <a:xfrm>
-            <a:off x="4572000" y="5029199"/>
-            <a:ext cx="2743200" cy="256032"/>
+            <a:off x="4076699" y="3857625"/>
+            <a:ext cx="1876424" cy="314325"/>
           </a:xfrm>
           <a:prstGeom prst="rect">
             <a:avLst/>
@@ -4497,35 +3978,41 @@
           <a:noFill/>
         </p:spPr>
         <p:txBody>
-          <a:bodyPr wrap="square" anchor="t">
+          <a:bodyPr wrap="none" anchor="t" lIns="0" rIns="0" tIns="0" bIns="0">
             <a:spAutoFit/>
           </a:bodyPr>
           <a:lstStyle/>
           <a:p>
             <a:pPr algn="l">
-              <a:defRPr sz="1200" b="1">
-                <a:solidFill>
-                  <a:srgbClr val="FF6B00"/>
-                </a:solidFill>
-                <a:latin typeface="Calibri"/>
-              </a:defRPr>
+              <a:spcBef>
+                <a:spcPts val="0"/>
+              </a:spcBef>
+              <a:spcAft>
+                <a:spcPts val="0"/>
+              </a:spcAft>
             </a:pPr>
             <a:r>
-              <a:t>867 hrs SAVED</a:t>
-            </a:r>
-          </a:p>
-        </p:txBody>
-      </p:sp>
-      <p:sp>
-        <p:nvSpPr>
-          <p:cNvPr id="36" name="TextBox 35"/>
+              <a:rPr sz="1125" b="0">
+                <a:solidFill>
+                  <a:srgbClr val="F9FBFC"/>
+                </a:solidFill>
+                <a:latin typeface="DejaVu Sans"/>
+              </a:rPr>
+              <a:t>Disposition &amp;</a:t>
+            </a:r>
+          </a:p>
+        </p:txBody>
+      </p:sp>
+      <p:sp>
+        <p:nvSpPr>
+          <p:cNvPr id="24" name="TextBox 23"/>
           <p:cNvSpPr txBox="1"/>
           <p:nvPr/>
         </p:nvSpPr>
         <p:spPr>
           <a:xfrm>
-            <a:off x="457200" y="5321807"/>
-            <a:ext cx="5943600" cy="256032"/>
+            <a:off x="4076699" y="4071937"/>
+            <a:ext cx="2571750" cy="314325"/>
           </a:xfrm>
           <a:prstGeom prst="rect">
             <a:avLst/>
@@ -4533,109 +4020,41 @@
           <a:noFill/>
         </p:spPr>
         <p:txBody>
-          <a:bodyPr wrap="square" anchor="t">
+          <a:bodyPr wrap="none" anchor="t" lIns="0" rIns="0" tIns="0" bIns="0">
             <a:spAutoFit/>
           </a:bodyPr>
           <a:lstStyle/>
           <a:p>
             <a:pPr algn="l">
-              <a:defRPr sz="1200" b="1">
-                <a:solidFill>
-                  <a:srgbClr val="FFCC00"/>
-                </a:solidFill>
-                <a:latin typeface="Calibri"/>
-              </a:defRPr>
+              <a:spcBef>
+                <a:spcPts val="0"/>
+              </a:spcBef>
+              <a:spcAft>
+                <a:spcPts val="0"/>
+              </a:spcAft>
             </a:pPr>
             <a:r>
-              <a:t>RL1: $7,595  |  Program: $30,345  per release (at $35/hr)</a:t>
-            </a:r>
-          </a:p>
-        </p:txBody>
-      </p:sp>
-      <p:sp>
-        <p:nvSpPr>
-          <p:cNvPr id="37" name="Rounded Rectangle 36"/>
-          <p:cNvSpPr/>
-          <p:nvPr/>
-        </p:nvSpPr>
-        <p:spPr>
-          <a:xfrm>
-            <a:off x="7498079" y="1280160"/>
-            <a:ext cx="1463040" cy="1097280"/>
-          </a:xfrm>
-          <a:prstGeom prst="roundRect">
-            <a:avLst/>
-          </a:prstGeom>
-          <a:solidFill>
-            <a:srgbClr val="11182E"/>
-          </a:solidFill>
-          <a:ln w="19050">
-            <a:solidFill>
-              <a:srgbClr val="00CCFF"/>
-            </a:solidFill>
-          </a:ln>
-        </p:spPr>
-        <p:style>
-          <a:lnRef idx="1">
-            <a:schemeClr val="accent1"/>
-          </a:lnRef>
-          <a:fillRef idx="3">
-            <a:schemeClr val="accent1"/>
-          </a:fillRef>
-          <a:effectRef idx="2">
-            <a:schemeClr val="accent1"/>
-          </a:effectRef>
-          <a:fontRef idx="minor">
-            <a:schemeClr val="lt1"/>
-          </a:fontRef>
-        </p:style>
-        <p:txBody>
-          <a:bodyPr rtlCol="0" anchor="ctr"/>
-          <a:lstStyle/>
-          <a:p>
-            <a:pPr algn="ctr">
-              <a:defRPr sz="2200"/>
-            </a:pPr>
-            <a:r>
-              <a:t>📄</a:t>
-            </a:r>
-          </a:p>
-          <a:p>
-            <a:pPr algn="ctr">
-              <a:defRPr sz="1000">
-                <a:solidFill>
-                  <a:srgbClr val="FFFFFF"/>
-                </a:solidFill>
-              </a:defRPr>
-            </a:pPr>
-            <a:r>
-              <a:t>Coverity</a:t>
-            </a:r>
-          </a:p>
-          <a:p>
-            <a:pPr algn="ctr">
-              <a:defRPr sz="1000">
-                <a:solidFill>
-                  <a:srgbClr val="FFFFFF"/>
-                </a:solidFill>
-              </a:defRPr>
-            </a:pPr>
-            <a:r>
-              <a:t>report</a:t>
-            </a:r>
-          </a:p>
-        </p:txBody>
-      </p:sp>
-      <p:sp>
-        <p:nvSpPr>
-          <p:cNvPr id="38" name="TextBox 37"/>
+              <a:rPr sz="1125" b="0">
+                <a:solidFill>
+                  <a:srgbClr val="F9FBFC"/>
+                </a:solidFill>
+                <a:latin typeface="DejaVu Sans"/>
+              </a:rPr>
+              <a:t>Documentation Required</a:t>
+            </a:r>
+          </a:p>
+        </p:txBody>
+      </p:sp>
+      <p:sp>
+        <p:nvSpPr>
+          <p:cNvPr id="25" name="TextBox 24"/>
           <p:cNvSpPr txBox="1"/>
           <p:nvPr/>
         </p:nvSpPr>
         <p:spPr>
           <a:xfrm>
-            <a:off x="7498079" y="1051560"/>
-            <a:ext cx="1463040" cy="228600"/>
+            <a:off x="6505575" y="2857500"/>
+            <a:ext cx="2419349" cy="314325"/>
           </a:xfrm>
           <a:prstGeom prst="rect">
             <a:avLst/>
@@ -4643,140 +4062,41 @@
           <a:noFill/>
         </p:spPr>
         <p:txBody>
-          <a:bodyPr wrap="square" anchor="t">
+          <a:bodyPr wrap="none" anchor="t" lIns="0" rIns="0" tIns="0" bIns="0">
             <a:spAutoFit/>
           </a:bodyPr>
           <a:lstStyle/>
           <a:p>
-            <a:pPr algn="ctr">
-              <a:defRPr sz="900" b="0">
-                <a:solidFill>
-                  <a:srgbClr val="CCCCDD"/>
-                </a:solidFill>
-                <a:latin typeface="Calibri"/>
-              </a:defRPr>
+            <a:pPr algn="l">
+              <a:spcBef>
+                <a:spcPts val="0"/>
+              </a:spcBef>
+              <a:spcAft>
+                <a:spcPts val="0"/>
+              </a:spcAft>
             </a:pPr>
             <a:r>
-              <a:t>Input</a:t>
-            </a:r>
-          </a:p>
-        </p:txBody>
-      </p:sp>
-      <p:sp>
-        <p:nvSpPr>
-          <p:cNvPr id="39" name="Right Arrow 38"/>
-          <p:cNvSpPr/>
-          <p:nvPr/>
-        </p:nvSpPr>
-        <p:spPr>
-          <a:xfrm>
-            <a:off x="8869680" y="1691640"/>
-            <a:ext cx="640080" cy="274320"/>
-          </a:xfrm>
-          <a:prstGeom prst="rightArrow">
-            <a:avLst/>
-          </a:prstGeom>
-          <a:solidFill>
-            <a:srgbClr val="FF6B00"/>
-          </a:solidFill>
-          <a:ln>
-            <a:noFill/>
-          </a:ln>
-        </p:spPr>
-        <p:style>
-          <a:lnRef idx="1">
-            <a:schemeClr val="accent1"/>
-          </a:lnRef>
-          <a:fillRef idx="3">
-            <a:schemeClr val="accent1"/>
-          </a:fillRef>
-          <a:effectRef idx="2">
-            <a:schemeClr val="accent1"/>
-          </a:effectRef>
-          <a:fontRef idx="minor">
-            <a:schemeClr val="lt1"/>
-          </a:fontRef>
-        </p:style>
-        <p:txBody>
-          <a:bodyPr rtlCol="0" anchor="ctr"/>
-          <a:lstStyle/>
-          <a:p>
-            <a:pPr algn="ctr"/>
-          </a:p>
-        </p:txBody>
-      </p:sp>
-      <p:sp>
-        <p:nvSpPr>
-          <p:cNvPr id="40" name="Rounded Rectangle 39"/>
-          <p:cNvSpPr/>
-          <p:nvPr/>
-        </p:nvSpPr>
-        <p:spPr>
-          <a:xfrm>
-            <a:off x="9418319" y="1280160"/>
-            <a:ext cx="1828800" cy="1097280"/>
-          </a:xfrm>
-          <a:prstGeom prst="roundRect">
-            <a:avLst/>
-          </a:prstGeom>
-          <a:solidFill>
-            <a:srgbClr val="11182E"/>
-          </a:solidFill>
-          <a:ln w="19050">
-            <a:solidFill>
-              <a:srgbClr val="00CCFF"/>
-            </a:solidFill>
-          </a:ln>
-        </p:spPr>
-        <p:style>
-          <a:lnRef idx="1">
-            <a:schemeClr val="accent1"/>
-          </a:lnRef>
-          <a:fillRef idx="3">
-            <a:schemeClr val="accent1"/>
-          </a:fillRef>
-          <a:effectRef idx="2">
-            <a:schemeClr val="accent1"/>
-          </a:effectRef>
-          <a:fontRef idx="minor">
-            <a:schemeClr val="lt1"/>
-          </a:fontRef>
-        </p:style>
-        <p:txBody>
-          <a:bodyPr rtlCol="0" anchor="ctr"/>
-          <a:lstStyle/>
-          <a:p>
-            <a:pPr algn="ctr">
-              <a:defRPr sz="2000"/>
-            </a:pPr>
-            <a:r>
-              <a:t>🌳</a:t>
-            </a:r>
-          </a:p>
-          <a:p>
-            <a:pPr algn="ctr">
-              <a:defRPr sz="1000">
-                <a:solidFill>
-                  <a:srgbClr val="00CCFF"/>
-                </a:solidFill>
-              </a:defRPr>
-            </a:pPr>
-            <a:r>
-              <a:t>Tree-sitter</a:t>
-            </a:r>
-          </a:p>
-        </p:txBody>
-      </p:sp>
-      <p:sp>
-        <p:nvSpPr>
-          <p:cNvPr id="41" name="TextBox 40"/>
+              <a:rPr sz="1125" b="0">
+                <a:solidFill>
+                  <a:srgbClr val="F9FBFC"/>
+                </a:solidFill>
+                <a:latin typeface="DejaVu Sans"/>
+              </a:rPr>
+              <a:t>1-2 minutes per defect</a:t>
+            </a:r>
+          </a:p>
+        </p:txBody>
+      </p:sp>
+      <p:sp>
+        <p:nvSpPr>
+          <p:cNvPr id="26" name="TextBox 25"/>
           <p:cNvSpPr txBox="1"/>
           <p:nvPr/>
         </p:nvSpPr>
         <p:spPr>
           <a:xfrm>
-            <a:off x="9143999" y="914400"/>
-            <a:ext cx="2377440" cy="182880"/>
+            <a:off x="6486525" y="3152179"/>
+            <a:ext cx="2228850" cy="314325"/>
           </a:xfrm>
           <a:prstGeom prst="rect">
             <a:avLst/>
@@ -4784,35 +4104,41 @@
           <a:noFill/>
         </p:spPr>
         <p:txBody>
-          <a:bodyPr wrap="square" anchor="t">
+          <a:bodyPr wrap="none" anchor="t" lIns="0" rIns="0" tIns="0" bIns="0">
             <a:spAutoFit/>
           </a:bodyPr>
           <a:lstStyle/>
           <a:p>
-            <a:pPr algn="ctr">
-              <a:defRPr sz="900" b="0">
-                <a:solidFill>
-                  <a:srgbClr val="CCCCDD"/>
-                </a:solidFill>
-                <a:latin typeface="Calibri"/>
-              </a:defRPr>
+            <a:pPr algn="l">
+              <a:spcBef>
+                <a:spcPts val="0"/>
+              </a:spcBef>
+              <a:spcAft>
+                <a:spcPts val="0"/>
+              </a:spcAft>
             </a:pPr>
             <a:r>
-              <a:t>Processing Stage 1</a:t>
-            </a:r>
-          </a:p>
-        </p:txBody>
-      </p:sp>
-      <p:sp>
-        <p:nvSpPr>
-          <p:cNvPr id="42" name="TextBox 41"/>
+              <a:rPr sz="1125" b="0">
+                <a:solidFill>
+                  <a:srgbClr val="F9FBFC"/>
+                </a:solidFill>
+                <a:latin typeface="DejaVu Sans"/>
+              </a:rPr>
+              <a:t>Automated Analysis</a:t>
+            </a:r>
+          </a:p>
+        </p:txBody>
+      </p:sp>
+      <p:sp>
+        <p:nvSpPr>
+          <p:cNvPr id="27" name="TextBox 26"/>
           <p:cNvSpPr txBox="1"/>
           <p:nvPr/>
         </p:nvSpPr>
         <p:spPr>
           <a:xfrm>
-            <a:off x="9143999" y="1051560"/>
-            <a:ext cx="2377440" cy="274320"/>
+            <a:off x="6496049" y="3509367"/>
+            <a:ext cx="2276474" cy="314325"/>
           </a:xfrm>
           <a:prstGeom prst="rect">
             <a:avLst/>
@@ -4820,152 +4146,41 @@
           <a:noFill/>
         </p:spPr>
         <p:txBody>
-          <a:bodyPr wrap="square" anchor="t">
+          <a:bodyPr wrap="none" anchor="t" lIns="0" rIns="0" tIns="0" bIns="0">
             <a:spAutoFit/>
           </a:bodyPr>
           <a:lstStyle/>
           <a:p>
-            <a:pPr algn="ctr">
-              <a:defRPr sz="1200" b="1">
-                <a:solidFill>
-                  <a:srgbClr val="FFFFFF"/>
-                </a:solidFill>
-                <a:latin typeface="Calibri"/>
-              </a:defRPr>
+            <a:pPr algn="l">
+              <a:spcBef>
+                <a:spcPts val="0"/>
+              </a:spcBef>
+              <a:spcAft>
+                <a:spcPts val="0"/>
+              </a:spcAft>
             </a:pPr>
             <a:r>
-              <a:t>Source Parser</a:t>
-            </a:r>
-          </a:p>
-        </p:txBody>
-      </p:sp>
-      <p:sp>
-        <p:nvSpPr>
-          <p:cNvPr id="43" name="Down Arrow 42"/>
-          <p:cNvSpPr/>
-          <p:nvPr/>
-        </p:nvSpPr>
-        <p:spPr>
-          <a:xfrm>
-            <a:off x="10241280" y="2331720"/>
-            <a:ext cx="274320" cy="457200"/>
-          </a:xfrm>
-          <a:prstGeom prst="downArrow">
-            <a:avLst/>
-          </a:prstGeom>
-          <a:solidFill>
-            <a:srgbClr val="FF6B00"/>
-          </a:solidFill>
-          <a:ln>
-            <a:noFill/>
-          </a:ln>
-        </p:spPr>
-        <p:style>
-          <a:lnRef idx="1">
-            <a:schemeClr val="accent1"/>
-          </a:lnRef>
-          <a:fillRef idx="3">
-            <a:schemeClr val="accent1"/>
-          </a:fillRef>
-          <a:effectRef idx="2">
-            <a:schemeClr val="accent1"/>
-          </a:effectRef>
-          <a:fontRef idx="minor">
-            <a:schemeClr val="lt1"/>
-          </a:fontRef>
-        </p:style>
-        <p:txBody>
-          <a:bodyPr rtlCol="0" anchor="ctr"/>
-          <a:lstStyle/>
-          <a:p>
-            <a:pPr algn="ctr"/>
-          </a:p>
-        </p:txBody>
-      </p:sp>
-      <p:sp>
-        <p:nvSpPr>
-          <p:cNvPr id="44" name="Rounded Rectangle 43"/>
-          <p:cNvSpPr/>
-          <p:nvPr/>
-        </p:nvSpPr>
-        <p:spPr>
-          <a:xfrm>
-            <a:off x="9601200" y="2743200"/>
-            <a:ext cx="2194560" cy="1097280"/>
-          </a:xfrm>
-          <a:prstGeom prst="roundRect">
-            <a:avLst/>
-          </a:prstGeom>
-          <a:solidFill>
-            <a:srgbClr val="11182E"/>
-          </a:solidFill>
-          <a:ln w="19050">
-            <a:solidFill>
-              <a:srgbClr val="FF6B00"/>
-            </a:solidFill>
-          </a:ln>
-        </p:spPr>
-        <p:style>
-          <a:lnRef idx="1">
-            <a:schemeClr val="accent1"/>
-          </a:lnRef>
-          <a:fillRef idx="3">
-            <a:schemeClr val="accent1"/>
-          </a:fillRef>
-          <a:effectRef idx="2">
-            <a:schemeClr val="accent1"/>
-          </a:effectRef>
-          <a:fontRef idx="minor">
-            <a:schemeClr val="lt1"/>
-          </a:fontRef>
-        </p:style>
-        <p:txBody>
-          <a:bodyPr rtlCol="0" anchor="ctr"/>
-          <a:lstStyle/>
-          <a:p>
-            <a:pPr algn="ctr">
-              <a:defRPr sz="2000"/>
-            </a:pPr>
-            <a:r>
-              <a:t>⚙️</a:t>
-            </a:r>
-          </a:p>
-          <a:p>
-            <a:pPr algn="ctr">
-              <a:defRPr sz="1200" b="1">
-                <a:solidFill>
-                  <a:srgbClr val="FF6B00"/>
-                </a:solidFill>
-              </a:defRPr>
-            </a:pPr>
-            <a:r>
-              <a:t>Rule Engine</a:t>
-            </a:r>
-          </a:p>
-          <a:p>
-            <a:pPr algn="ctr">
-              <a:defRPr sz="900">
-                <a:solidFill>
-                  <a:srgbClr val="CCCCDD"/>
-                </a:solidFill>
-              </a:defRPr>
-            </a:pPr>
-            <a:r>
-              <a:t>20+ Checker Rules</a:t>
-            </a:r>
-          </a:p>
-        </p:txBody>
-      </p:sp>
-      <p:sp>
-        <p:nvSpPr>
-          <p:cNvPr id="45" name="TextBox 44"/>
+              <a:rPr sz="1125" b="0">
+                <a:solidFill>
+                  <a:srgbClr val="F9FBFC"/>
+                </a:solidFill>
+                <a:latin typeface="DejaVu Sans"/>
+              </a:rPr>
+              <a:t>One Controlled Flow</a:t>
+            </a:r>
+          </a:p>
+        </p:txBody>
+      </p:sp>
+      <p:sp>
+        <p:nvSpPr>
+          <p:cNvPr id="28" name="TextBox 27"/>
           <p:cNvSpPr txBox="1"/>
           <p:nvPr/>
         </p:nvSpPr>
         <p:spPr>
           <a:xfrm>
-            <a:off x="9326880" y="2468880"/>
-            <a:ext cx="2743200" cy="228600"/>
+            <a:off x="6496049" y="3884414"/>
+            <a:ext cx="1809749" cy="314325"/>
           </a:xfrm>
           <a:prstGeom prst="rect">
             <a:avLst/>
@@ -4973,152 +4188,41 @@
           <a:noFill/>
         </p:spPr>
         <p:txBody>
-          <a:bodyPr wrap="square" anchor="t">
+          <a:bodyPr wrap="none" anchor="t" lIns="0" rIns="0" tIns="0" bIns="0">
             <a:spAutoFit/>
           </a:bodyPr>
           <a:lstStyle/>
           <a:p>
-            <a:pPr algn="ctr">
-              <a:defRPr sz="900" b="0">
-                <a:solidFill>
-                  <a:srgbClr val="CCCCDD"/>
-                </a:solidFill>
-                <a:latin typeface="Calibri"/>
-              </a:defRPr>
+            <a:pPr algn="l">
+              <a:spcBef>
+                <a:spcPts val="0"/>
+              </a:spcBef>
+              <a:spcAft>
+                <a:spcPts val="0"/>
+              </a:spcAft>
             </a:pPr>
             <a:r>
-              <a:t>Processing Stage 2</a:t>
-            </a:r>
-          </a:p>
-        </p:txBody>
-      </p:sp>
-      <p:sp>
-        <p:nvSpPr>
-          <p:cNvPr id="46" name="Left Arrow 45"/>
-          <p:cNvSpPr/>
-          <p:nvPr/>
-        </p:nvSpPr>
-        <p:spPr>
-          <a:xfrm>
-            <a:off x="9692640" y="3794760"/>
-            <a:ext cx="457200" cy="274320"/>
-          </a:xfrm>
-          <a:prstGeom prst="leftArrow">
-            <a:avLst/>
-          </a:prstGeom>
-          <a:solidFill>
-            <a:srgbClr val="FF6B00"/>
-          </a:solidFill>
-          <a:ln>
-            <a:noFill/>
-          </a:ln>
-        </p:spPr>
-        <p:style>
-          <a:lnRef idx="1">
-            <a:schemeClr val="accent1"/>
-          </a:lnRef>
-          <a:fillRef idx="3">
-            <a:schemeClr val="accent1"/>
-          </a:fillRef>
-          <a:effectRef idx="2">
-            <a:schemeClr val="accent1"/>
-          </a:effectRef>
-          <a:fontRef idx="minor">
-            <a:schemeClr val="lt1"/>
-          </a:fontRef>
-        </p:style>
-        <p:txBody>
-          <a:bodyPr rtlCol="0" anchor="ctr"/>
-          <a:lstStyle/>
-          <a:p>
-            <a:pPr algn="ctr"/>
-          </a:p>
-        </p:txBody>
-      </p:sp>
-      <p:sp>
-        <p:nvSpPr>
-          <p:cNvPr id="47" name="Rounded Rectangle 46"/>
-          <p:cNvSpPr/>
-          <p:nvPr/>
-        </p:nvSpPr>
-        <p:spPr>
-          <a:xfrm>
-            <a:off x="7772400" y="4023360"/>
-            <a:ext cx="2011680" cy="1097280"/>
-          </a:xfrm>
-          <a:prstGeom prst="roundRect">
-            <a:avLst/>
-          </a:prstGeom>
-          <a:solidFill>
-            <a:srgbClr val="11182E"/>
-          </a:solidFill>
-          <a:ln w="19050">
-            <a:solidFill>
-              <a:srgbClr val="FF9933"/>
-            </a:solidFill>
-          </a:ln>
-        </p:spPr>
-        <p:style>
-          <a:lnRef idx="1">
-            <a:schemeClr val="accent1"/>
-          </a:lnRef>
-          <a:fillRef idx="3">
-            <a:schemeClr val="accent1"/>
-          </a:fillRef>
-          <a:effectRef idx="2">
-            <a:schemeClr val="accent1"/>
-          </a:effectRef>
-          <a:fontRef idx="minor">
-            <a:schemeClr val="lt1"/>
-          </a:fontRef>
-        </p:style>
-        <p:txBody>
-          <a:bodyPr rtlCol="0" anchor="ctr"/>
-          <a:lstStyle/>
-          <a:p>
-            <a:pPr algn="ctr">
-              <a:defRPr sz="2000"/>
-            </a:pPr>
-            <a:r>
-              <a:t>🧠</a:t>
-            </a:r>
-          </a:p>
-          <a:p>
-            <a:pPr algn="ctr">
-              <a:defRPr sz="1100" b="1">
-                <a:solidFill>
-                  <a:srgbClr val="FF9933"/>
-                </a:solidFill>
-              </a:defRPr>
-            </a:pPr>
-            <a:r>
-              <a:t>AI-Optimized</a:t>
-            </a:r>
-          </a:p>
-          <a:p>
-            <a:pPr algn="ctr">
-              <a:defRPr sz="1100">
-                <a:solidFill>
-                  <a:srgbClr val="FF9933"/>
-                </a:solidFill>
-              </a:defRPr>
-            </a:pPr>
-            <a:r>
-              <a:t>Analysis</a:t>
-            </a:r>
-          </a:p>
-        </p:txBody>
-      </p:sp>
-      <p:sp>
-        <p:nvSpPr>
-          <p:cNvPr id="48" name="TextBox 47"/>
+              <a:rPr sz="1125" b="0">
+                <a:solidFill>
+                  <a:srgbClr val="F9FBFC"/>
+                </a:solidFill>
+                <a:latin typeface="DejaVu Sans"/>
+              </a:rPr>
+              <a:t>Higher Quality</a:t>
+            </a:r>
+          </a:p>
+        </p:txBody>
+      </p:sp>
+      <p:sp>
+        <p:nvSpPr>
+          <p:cNvPr id="29" name="TextBox 28"/>
           <p:cNvSpPr txBox="1"/>
           <p:nvPr/>
         </p:nvSpPr>
         <p:spPr>
           <a:xfrm>
-            <a:off x="7498079" y="3749039"/>
-            <a:ext cx="2560320" cy="228600"/>
+            <a:off x="3673078" y="4393406"/>
+            <a:ext cx="4693443" cy="589359"/>
           </a:xfrm>
           <a:prstGeom prst="rect">
             <a:avLst/>
@@ -5126,152 +4230,41 @@
           <a:noFill/>
         </p:spPr>
         <p:txBody>
-          <a:bodyPr wrap="square" anchor="t">
+          <a:bodyPr wrap="none" anchor="t" lIns="0" rIns="0" tIns="0" bIns="0">
             <a:spAutoFit/>
           </a:bodyPr>
           <a:lstStyle/>
           <a:p>
             <a:pPr algn="ctr">
-              <a:defRPr sz="900" b="0">
-                <a:solidFill>
-                  <a:srgbClr val="CCCCDD"/>
-                </a:solidFill>
-                <a:latin typeface="Calibri"/>
-              </a:defRPr>
+              <a:spcBef>
+                <a:spcPts val="0"/>
+              </a:spcBef>
+              <a:spcAft>
+                <a:spcPts val="0"/>
+              </a:spcAft>
             </a:pPr>
             <a:r>
-              <a:t>Processing Stage 3</a:t>
-            </a:r>
-          </a:p>
-        </p:txBody>
-      </p:sp>
-      <p:sp>
-        <p:nvSpPr>
-          <p:cNvPr id="49" name="Right Arrow 48"/>
-          <p:cNvSpPr/>
-          <p:nvPr/>
-        </p:nvSpPr>
-        <p:spPr>
-          <a:xfrm>
-            <a:off x="9738360" y="4434840"/>
-            <a:ext cx="548640" cy="274320"/>
-          </a:xfrm>
-          <a:prstGeom prst="rightArrow">
-            <a:avLst/>
-          </a:prstGeom>
-          <a:solidFill>
-            <a:srgbClr val="FF6B00"/>
-          </a:solidFill>
-          <a:ln>
-            <a:noFill/>
-          </a:ln>
-        </p:spPr>
-        <p:style>
-          <a:lnRef idx="1">
-            <a:schemeClr val="accent1"/>
-          </a:lnRef>
-          <a:fillRef idx="3">
-            <a:schemeClr val="accent1"/>
-          </a:fillRef>
-          <a:effectRef idx="2">
-            <a:schemeClr val="accent1"/>
-          </a:effectRef>
-          <a:fontRef idx="minor">
-            <a:schemeClr val="lt1"/>
-          </a:fontRef>
-        </p:style>
-        <p:txBody>
-          <a:bodyPr rtlCol="0" anchor="ctr"/>
-          <a:lstStyle/>
-          <a:p>
-            <a:pPr algn="ctr"/>
-          </a:p>
-        </p:txBody>
-      </p:sp>
-      <p:sp>
-        <p:nvSpPr>
-          <p:cNvPr id="50" name="Rounded Rectangle 49"/>
-          <p:cNvSpPr/>
-          <p:nvPr/>
-        </p:nvSpPr>
-        <p:spPr>
-          <a:xfrm>
-            <a:off x="10241280" y="4023360"/>
-            <a:ext cx="1645920" cy="1097280"/>
-          </a:xfrm>
-          <a:prstGeom prst="roundRect">
-            <a:avLst/>
-          </a:prstGeom>
-          <a:solidFill>
-            <a:srgbClr val="11182E"/>
-          </a:solidFill>
-          <a:ln w="19050">
-            <a:solidFill>
-              <a:srgbClr val="00CC66"/>
-            </a:solidFill>
-          </a:ln>
-        </p:spPr>
-        <p:style>
-          <a:lnRef idx="1">
-            <a:schemeClr val="accent1"/>
-          </a:lnRef>
-          <a:fillRef idx="3">
-            <a:schemeClr val="accent1"/>
-          </a:fillRef>
-          <a:effectRef idx="2">
-            <a:schemeClr val="accent1"/>
-          </a:effectRef>
-          <a:fontRef idx="minor">
-            <a:schemeClr val="lt1"/>
-          </a:fontRef>
-        </p:style>
-        <p:txBody>
-          <a:bodyPr rtlCol="0" anchor="ctr"/>
-          <a:lstStyle/>
-          <a:p>
-            <a:pPr algn="ctr">
-              <a:defRPr sz="2200"/>
-            </a:pPr>
-            <a:r>
-              <a:t>✅</a:t>
-            </a:r>
-          </a:p>
-          <a:p>
-            <a:pPr algn="ctr">
-              <a:defRPr sz="1100" b="1">
-                <a:solidFill>
-                  <a:srgbClr val="00CC66"/>
-                </a:solidFill>
-              </a:defRPr>
-            </a:pPr>
-            <a:r>
-              <a:t>Smart</a:t>
-            </a:r>
-          </a:p>
-          <a:p>
-            <a:pPr algn="ctr">
-              <a:defRPr sz="1100">
-                <a:solidFill>
-                  <a:srgbClr val="00CC66"/>
-                </a:solidFill>
-              </a:defRPr>
-            </a:pPr>
-            <a:r>
-              <a:t>Dispositions</a:t>
-            </a:r>
-          </a:p>
-        </p:txBody>
-      </p:sp>
-      <p:sp>
-        <p:nvSpPr>
-          <p:cNvPr id="51" name="TextBox 50"/>
+              <a:rPr sz="2109" b="1">
+                <a:solidFill>
+                  <a:srgbClr val="F6962D"/>
+                </a:solidFill>
+                <a:latin typeface="DejaVu Sans"/>
+              </a:rPr>
+              <a:t>~90% Time Reduction</a:t>
+            </a:r>
+          </a:p>
+        </p:txBody>
+      </p:sp>
+      <p:sp>
+        <p:nvSpPr>
+          <p:cNvPr id="30" name="TextBox 29"/>
           <p:cNvSpPr txBox="1"/>
           <p:nvPr/>
         </p:nvSpPr>
         <p:spPr>
           <a:xfrm>
-            <a:off x="7040879" y="5440680"/>
-            <a:ext cx="5029200" cy="274320"/>
+            <a:off x="11010900" y="1991320"/>
+            <a:ext cx="1943100" cy="314325"/>
           </a:xfrm>
           <a:prstGeom prst="rect">
             <a:avLst/>
@@ -5279,35 +4272,41 @@
           <a:noFill/>
         </p:spPr>
         <p:txBody>
-          <a:bodyPr wrap="square" anchor="t">
+          <a:bodyPr wrap="none" anchor="t" lIns="0" rIns="0" tIns="0" bIns="0">
             <a:spAutoFit/>
           </a:bodyPr>
           <a:lstStyle/>
           <a:p>
             <a:pPr algn="l">
-              <a:defRPr sz="1300" b="1">
-                <a:solidFill>
-                  <a:srgbClr val="CCCCDD"/>
-                </a:solidFill>
-                <a:latin typeface="Calibri"/>
-              </a:defRPr>
+              <a:spcBef>
+                <a:spcPts val="0"/>
+              </a:spcBef>
+              <a:spcAft>
+                <a:spcPts val="0"/>
+              </a:spcAft>
             </a:pPr>
             <a:r>
-              <a:t>AI used to DEVELOP, analysis is RULE-BASED</a:t>
-            </a:r>
-          </a:p>
-        </p:txBody>
-      </p:sp>
-      <p:sp>
-        <p:nvSpPr>
-          <p:cNvPr id="52" name="TextBox 51"/>
+              <a:rPr sz="1125" b="0">
+                <a:solidFill>
+                  <a:srgbClr val="F9FBFC"/>
+                </a:solidFill>
+                <a:latin typeface="DejaVu Sans"/>
+              </a:rPr>
+              <a:t>* AI used to DEVELOP,</a:t>
+            </a:r>
+          </a:p>
+        </p:txBody>
+      </p:sp>
+      <p:sp>
+        <p:nvSpPr>
+          <p:cNvPr id="31" name="TextBox 30"/>
           <p:cNvSpPr txBox="1"/>
           <p:nvPr/>
         </p:nvSpPr>
         <p:spPr>
           <a:xfrm>
-            <a:off x="274320" y="6400800"/>
-            <a:ext cx="11430000" cy="201168"/>
+            <a:off x="11010900" y="2143125"/>
+            <a:ext cx="1943100" cy="314325"/>
           </a:xfrm>
           <a:prstGeom prst="rect">
             <a:avLst/>
@@ -5315,35 +4314,41 @@
           <a:noFill/>
         </p:spPr>
         <p:txBody>
-          <a:bodyPr wrap="square" anchor="t">
+          <a:bodyPr wrap="none" anchor="t" lIns="0" rIns="0" tIns="0" bIns="0">
             <a:spAutoFit/>
           </a:bodyPr>
           <a:lstStyle/>
           <a:p>
-            <a:pPr algn="ctr">
-              <a:defRPr sz="900" b="0">
-                <a:solidFill>
-                  <a:srgbClr val="8888AA"/>
-                </a:solidFill>
-                <a:latin typeface="Calibri"/>
-              </a:defRPr>
+            <a:pPr algn="l">
+              <a:spcBef>
+                <a:spcPts val="0"/>
+              </a:spcBef>
+              <a:spcAft>
+                <a:spcPts val="0"/>
+              </a:spcAft>
             </a:pPr>
             <a:r>
-              <a:t>Rakesh Boya  |  Tool Owner &amp; Developer  |  Honeywell Aerospace  |  CNS AI Day 2026</a:t>
-            </a:r>
-          </a:p>
-        </p:txBody>
-      </p:sp>
-      <p:sp>
-        <p:nvSpPr>
-          <p:cNvPr id="53" name="TextBox 52"/>
+              <a:rPr sz="1125" b="0">
+                <a:solidFill>
+                  <a:srgbClr val="F9FBFC"/>
+                </a:solidFill>
+                <a:latin typeface="DejaVu Sans"/>
+              </a:rPr>
+              <a:t>analysis is RULE-BASED</a:t>
+            </a:r>
+          </a:p>
+        </p:txBody>
+      </p:sp>
+      <p:sp>
+        <p:nvSpPr>
+          <p:cNvPr id="32" name="TextBox 31"/>
           <p:cNvSpPr txBox="1"/>
           <p:nvPr/>
         </p:nvSpPr>
         <p:spPr>
           <a:xfrm>
-            <a:off x="274320" y="6583680"/>
-            <a:ext cx="11430000" cy="201168"/>
+            <a:off x="8029575" y="3429000"/>
+            <a:ext cx="2286000" cy="314325"/>
           </a:xfrm>
           <a:prstGeom prst="rect">
             <a:avLst/>
@@ -5351,21 +4356,591 @@
           <a:noFill/>
         </p:spPr>
         <p:txBody>
-          <a:bodyPr wrap="square" anchor="t">
+          <a:bodyPr wrap="none" anchor="t" lIns="0" rIns="0" tIns="0" bIns="0">
             <a:spAutoFit/>
           </a:bodyPr>
           <a:lstStyle/>
           <a:p>
             <a:pPr algn="ctr">
-              <a:defRPr sz="900" b="1">
-                <a:solidFill>
-                  <a:srgbClr val="8888AA"/>
-                </a:solidFill>
-                <a:latin typeface="Calibri"/>
-              </a:defRPr>
+              <a:spcBef>
+                <a:spcPts val="0"/>
+              </a:spcBef>
+              <a:spcAft>
+                <a:spcPts val="0"/>
+              </a:spcAft>
             </a:pPr>
             <a:r>
-              <a:t>Confidential</a:t>
+              <a:rPr sz="1125" b="1">
+                <a:solidFill>
+                  <a:srgbClr val="F9FBFC"/>
+                </a:solidFill>
+                <a:latin typeface="DejaVu Sans"/>
+              </a:rPr>
+              <a:t>HTML/Excel</a:t>
+            </a:r>
+          </a:p>
+        </p:txBody>
+      </p:sp>
+      <p:sp>
+        <p:nvSpPr>
+          <p:cNvPr id="33" name="TextBox 32"/>
+          <p:cNvSpPr txBox="1"/>
+          <p:nvPr/>
+        </p:nvSpPr>
+        <p:spPr>
+          <a:xfrm>
+            <a:off x="7991474" y="3714750"/>
+            <a:ext cx="2286000" cy="294679"/>
+          </a:xfrm>
+          <a:prstGeom prst="rect">
+            <a:avLst/>
+          </a:prstGeom>
+          <a:noFill/>
+        </p:spPr>
+        <p:txBody>
+          <a:bodyPr wrap="none" anchor="t" lIns="0" rIns="0" tIns="0" bIns="0">
+            <a:spAutoFit/>
+          </a:bodyPr>
+          <a:lstStyle/>
+          <a:p>
+            <a:pPr algn="ctr">
+              <a:spcBef>
+                <a:spcPts val="0"/>
+              </a:spcBef>
+              <a:spcAft>
+                <a:spcPts val="0"/>
+              </a:spcAft>
+            </a:pPr>
+            <a:r>
+              <a:rPr sz="1054" b="1">
+                <a:solidFill>
+                  <a:srgbClr val="F9FBFC"/>
+                </a:solidFill>
+                <a:latin typeface="DejaVu Sans"/>
+              </a:rPr>
+              <a:t>Reports</a:t>
+            </a:r>
+          </a:p>
+        </p:txBody>
+      </p:sp>
+      <p:sp>
+        <p:nvSpPr>
+          <p:cNvPr id="34" name="TextBox 33"/>
+          <p:cNvSpPr txBox="1"/>
+          <p:nvPr/>
+        </p:nvSpPr>
+        <p:spPr>
+          <a:xfrm>
+            <a:off x="9391649" y="4446984"/>
+            <a:ext cx="2286000" cy="333970"/>
+          </a:xfrm>
+          <a:prstGeom prst="rect">
+            <a:avLst/>
+          </a:prstGeom>
+          <a:noFill/>
+        </p:spPr>
+        <p:txBody>
+          <a:bodyPr wrap="none" anchor="t" lIns="0" rIns="0" tIns="0" bIns="0">
+            <a:spAutoFit/>
+          </a:bodyPr>
+          <a:lstStyle/>
+          <a:p>
+            <a:pPr algn="ctr">
+              <a:spcBef>
+                <a:spcPts val="0"/>
+              </a:spcBef>
+              <a:spcAft>
+                <a:spcPts val="0"/>
+              </a:spcAft>
+            </a:pPr>
+            <a:r>
+              <a:rPr sz="1195" b="1">
+                <a:solidFill>
+                  <a:srgbClr val="F9FBFC"/>
+                </a:solidFill>
+                <a:latin typeface="DejaVu Sans"/>
+              </a:rPr>
+              <a:t>Rules Engine</a:t>
+            </a:r>
+          </a:p>
+        </p:txBody>
+      </p:sp>
+      <p:sp>
+        <p:nvSpPr>
+          <p:cNvPr id="35" name="TextBox 34"/>
+          <p:cNvSpPr txBox="1"/>
+          <p:nvPr/>
+        </p:nvSpPr>
+        <p:spPr>
+          <a:xfrm>
+            <a:off x="9401175" y="4723804"/>
+            <a:ext cx="2286000" cy="294679"/>
+          </a:xfrm>
+          <a:prstGeom prst="rect">
+            <a:avLst/>
+          </a:prstGeom>
+          <a:noFill/>
+        </p:spPr>
+        <p:txBody>
+          <a:bodyPr wrap="none" anchor="t" lIns="0" rIns="0" tIns="0" bIns="0">
+            <a:spAutoFit/>
+          </a:bodyPr>
+          <a:lstStyle/>
+          <a:p>
+            <a:pPr algn="ctr">
+              <a:spcBef>
+                <a:spcPts val="0"/>
+              </a:spcBef>
+              <a:spcAft>
+                <a:spcPts val="0"/>
+              </a:spcAft>
+            </a:pPr>
+            <a:r>
+              <a:rPr sz="1054" b="1">
+                <a:solidFill>
+                  <a:srgbClr val="F9FBFC"/>
+                </a:solidFill>
+                <a:latin typeface="DejaVu Sans"/>
+              </a:rPr>
+              <a:t>AI Developed</a:t>
+            </a:r>
+          </a:p>
+        </p:txBody>
+      </p:sp>
+      <p:sp>
+        <p:nvSpPr>
+          <p:cNvPr id="36" name="TextBox 35"/>
+          <p:cNvSpPr txBox="1"/>
+          <p:nvPr/>
+        </p:nvSpPr>
+        <p:spPr>
+          <a:xfrm>
+            <a:off x="9482137" y="4947046"/>
+            <a:ext cx="2286000" cy="294679"/>
+          </a:xfrm>
+          <a:prstGeom prst="rect">
+            <a:avLst/>
+          </a:prstGeom>
+          <a:noFill/>
+        </p:spPr>
+        <p:txBody>
+          <a:bodyPr wrap="none" anchor="t" lIns="0" rIns="0" tIns="0" bIns="0">
+            <a:spAutoFit/>
+          </a:bodyPr>
+          <a:lstStyle/>
+          <a:p>
+            <a:pPr algn="ctr">
+              <a:spcBef>
+                <a:spcPts val="0"/>
+              </a:spcBef>
+              <a:spcAft>
+                <a:spcPts val="0"/>
+              </a:spcAft>
+            </a:pPr>
+            <a:r>
+              <a:rPr sz="1054" b="0">
+                <a:solidFill>
+                  <a:srgbClr val="F9FBFC"/>
+                </a:solidFill>
+                <a:latin typeface="DejaVu Sans"/>
+              </a:rPr>
+              <a:t>20+ Checker Rules</a:t>
+            </a:r>
+          </a:p>
+        </p:txBody>
+      </p:sp>
+      <p:sp>
+        <p:nvSpPr>
+          <p:cNvPr id="37" name="TextBox 36"/>
+          <p:cNvSpPr txBox="1"/>
+          <p:nvPr/>
+        </p:nvSpPr>
+        <p:spPr>
+          <a:xfrm>
+            <a:off x="11087100" y="5313164"/>
+            <a:ext cx="1838324" cy="392906"/>
+          </a:xfrm>
+          <a:prstGeom prst="rect">
+            <a:avLst/>
+          </a:prstGeom>
+          <a:noFill/>
+        </p:spPr>
+        <p:txBody>
+          <a:bodyPr wrap="none" anchor="t" lIns="0" rIns="0" tIns="0" bIns="0">
+            <a:spAutoFit/>
+          </a:bodyPr>
+          <a:lstStyle/>
+          <a:p>
+            <a:pPr algn="l">
+              <a:spcBef>
+                <a:spcPts val="0"/>
+              </a:spcBef>
+              <a:spcAft>
+                <a:spcPts val="0"/>
+              </a:spcAft>
+            </a:pPr>
+            <a:r>
+              <a:rPr sz="1406" b="1">
+                <a:solidFill>
+                  <a:srgbClr val="F9FBFC"/>
+                </a:solidFill>
+                <a:latin typeface="DejaVu Sans"/>
+              </a:rPr>
+              <a:t>Smart</a:t>
+            </a:r>
+          </a:p>
+        </p:txBody>
+      </p:sp>
+      <p:sp>
+        <p:nvSpPr>
+          <p:cNvPr id="38" name="TextBox 37"/>
+          <p:cNvSpPr txBox="1"/>
+          <p:nvPr/>
+        </p:nvSpPr>
+        <p:spPr>
+          <a:xfrm>
+            <a:off x="11220449" y="5643562"/>
+            <a:ext cx="1733550" cy="392906"/>
+          </a:xfrm>
+          <a:prstGeom prst="rect">
+            <a:avLst/>
+          </a:prstGeom>
+          <a:noFill/>
+        </p:spPr>
+        <p:txBody>
+          <a:bodyPr wrap="none" anchor="t" lIns="0" rIns="0" tIns="0" bIns="0">
+            <a:spAutoFit/>
+          </a:bodyPr>
+          <a:lstStyle/>
+          <a:p>
+            <a:pPr algn="l">
+              <a:spcBef>
+                <a:spcPts val="0"/>
+              </a:spcBef>
+              <a:spcAft>
+                <a:spcPts val="0"/>
+              </a:spcAft>
+            </a:pPr>
+            <a:r>
+              <a:rPr sz="1406" b="1">
+                <a:solidFill>
+                  <a:srgbClr val="F9FBFC"/>
+                </a:solidFill>
+                <a:latin typeface="DejaVu Sans"/>
+              </a:rPr>
+              <a:t>Dispositions</a:t>
+            </a:r>
+          </a:p>
+        </p:txBody>
+      </p:sp>
+      <p:sp>
+        <p:nvSpPr>
+          <p:cNvPr id="39" name="TextBox 38"/>
+          <p:cNvSpPr txBox="1"/>
+          <p:nvPr/>
+        </p:nvSpPr>
+        <p:spPr>
+          <a:xfrm>
+            <a:off x="9477374" y="5572125"/>
+            <a:ext cx="2476499" cy="353615"/>
+          </a:xfrm>
+          <a:prstGeom prst="rect">
+            <a:avLst/>
+          </a:prstGeom>
+          <a:noFill/>
+        </p:spPr>
+        <p:txBody>
+          <a:bodyPr wrap="none" anchor="t" lIns="0" rIns="0" tIns="0" bIns="0">
+            <a:spAutoFit/>
+          </a:bodyPr>
+          <a:lstStyle/>
+          <a:p>
+            <a:pPr algn="l">
+              <a:spcBef>
+                <a:spcPts val="0"/>
+              </a:spcBef>
+              <a:spcAft>
+                <a:spcPts val="0"/>
+              </a:spcAft>
+            </a:pPr>
+            <a:r>
+              <a:rPr sz="1265" b="0">
+                <a:solidFill>
+                  <a:srgbClr val="F9FBFC"/>
+                </a:solidFill>
+                <a:latin typeface="DejaVu Sans"/>
+              </a:rPr>
+              <a:t>AI used to DEVELOP,</a:t>
+            </a:r>
+          </a:p>
+        </p:txBody>
+      </p:sp>
+      <p:sp>
+        <p:nvSpPr>
+          <p:cNvPr id="40" name="TextBox 39"/>
+          <p:cNvSpPr txBox="1"/>
+          <p:nvPr/>
+        </p:nvSpPr>
+        <p:spPr>
+          <a:xfrm>
+            <a:off x="9458325" y="5786437"/>
+            <a:ext cx="2543175" cy="314325"/>
+          </a:xfrm>
+          <a:prstGeom prst="rect">
+            <a:avLst/>
+          </a:prstGeom>
+          <a:noFill/>
+        </p:spPr>
+        <p:txBody>
+          <a:bodyPr wrap="none" anchor="t" lIns="0" rIns="0" tIns="0" bIns="0">
+            <a:spAutoFit/>
+          </a:bodyPr>
+          <a:lstStyle/>
+          <a:p>
+            <a:pPr algn="l">
+              <a:spcBef>
+                <a:spcPts val="0"/>
+              </a:spcBef>
+              <a:spcAft>
+                <a:spcPts val="0"/>
+              </a:spcAft>
+            </a:pPr>
+            <a:r>
+              <a:rPr sz="1125" b="0">
+                <a:solidFill>
+                  <a:srgbClr val="F9FBFC"/>
+                </a:solidFill>
+                <a:latin typeface="DejaVu Sans"/>
+              </a:rPr>
+              <a:t>analysis is RULE-BASED</a:t>
+            </a:r>
+          </a:p>
+        </p:txBody>
+      </p:sp>
+      <p:sp>
+        <p:nvSpPr>
+          <p:cNvPr id="41" name="TextBox 40"/>
+          <p:cNvSpPr txBox="1"/>
+          <p:nvPr/>
+        </p:nvSpPr>
+        <p:spPr>
+          <a:xfrm>
+            <a:off x="885825" y="5054203"/>
+            <a:ext cx="5114925" cy="530423"/>
+          </a:xfrm>
+          <a:prstGeom prst="rect">
+            <a:avLst/>
+          </a:prstGeom>
+          <a:noFill/>
+        </p:spPr>
+        <p:txBody>
+          <a:bodyPr wrap="none" anchor="t" lIns="0" rIns="0" tIns="0" bIns="0">
+            <a:spAutoFit/>
+          </a:bodyPr>
+          <a:lstStyle/>
+          <a:p>
+            <a:pPr algn="l">
+              <a:spcBef>
+                <a:spcPts val="0"/>
+              </a:spcBef>
+              <a:spcAft>
+                <a:spcPts val="0"/>
+              </a:spcAft>
+            </a:pPr>
+            <a:r>
+              <a:rPr sz="1898" b="1">
+                <a:solidFill>
+                  <a:srgbClr val="EE6E1E"/>
+                </a:solidFill>
+                <a:latin typeface="DejaVu Sans"/>
+              </a:rPr>
+              <a:t>COST SAVINGS PER PROGRAM</a:t>
+            </a:r>
+          </a:p>
+        </p:txBody>
+      </p:sp>
+      <p:sp>
+        <p:nvSpPr>
+          <p:cNvPr id="42" name="TextBox 41"/>
+          <p:cNvSpPr txBox="1"/>
+          <p:nvPr/>
+        </p:nvSpPr>
+        <p:spPr>
+          <a:xfrm>
+            <a:off x="790574" y="5464968"/>
+            <a:ext cx="6991350" cy="451842"/>
+          </a:xfrm>
+          <a:prstGeom prst="rect">
+            <a:avLst/>
+          </a:prstGeom>
+          <a:noFill/>
+        </p:spPr>
+        <p:txBody>
+          <a:bodyPr wrap="none" anchor="t" lIns="0" rIns="0" tIns="0" bIns="0">
+            <a:spAutoFit/>
+          </a:bodyPr>
+          <a:lstStyle/>
+          <a:p>
+            <a:pPr algn="l">
+              <a:spcBef>
+                <a:spcPts val="0"/>
+              </a:spcBef>
+              <a:spcAft>
+                <a:spcPts val="0"/>
+              </a:spcAft>
+            </a:pPr>
+            <a:r>
+              <a:rPr sz="1617" b="0">
+                <a:solidFill>
+                  <a:srgbClr val="F9FBFC"/>
+                </a:solidFill>
+                <a:latin typeface="DejaVu Sans"/>
+              </a:rPr>
+              <a:t>RL1 (1,000 defects): 250 hrs → 33 hrs = </a:t>
+            </a:r>
+            <a:r>
+              <a:rPr sz="1617" b="1">
+                <a:solidFill>
+                  <a:srgbClr val="F6962D"/>
+                </a:solidFill>
+                <a:latin typeface="DejaVu Sans"/>
+              </a:rPr>
+              <a:t>217 hrs SAVED</a:t>
+            </a:r>
+          </a:p>
+        </p:txBody>
+      </p:sp>
+      <p:sp>
+        <p:nvSpPr>
+          <p:cNvPr id="43" name="TextBox 42"/>
+          <p:cNvSpPr txBox="1"/>
+          <p:nvPr/>
+        </p:nvSpPr>
+        <p:spPr>
+          <a:xfrm>
+            <a:off x="790574" y="5786437"/>
+            <a:ext cx="7781924" cy="451842"/>
+          </a:xfrm>
+          <a:prstGeom prst="rect">
+            <a:avLst/>
+          </a:prstGeom>
+          <a:noFill/>
+        </p:spPr>
+        <p:txBody>
+          <a:bodyPr wrap="none" anchor="t" lIns="0" rIns="0" tIns="0" bIns="0">
+            <a:spAutoFit/>
+          </a:bodyPr>
+          <a:lstStyle/>
+          <a:p>
+            <a:pPr algn="l">
+              <a:spcBef>
+                <a:spcPts val="0"/>
+              </a:spcBef>
+              <a:spcAft>
+                <a:spcPts val="0"/>
+              </a:spcAft>
+            </a:pPr>
+            <a:r>
+              <a:rPr sz="1617" b="0">
+                <a:solidFill>
+                  <a:srgbClr val="F9FBFC"/>
+                </a:solidFill>
+                <a:latin typeface="DejaVu Sans"/>
+              </a:rPr>
+              <a:t>Program (4,000 defects): 1000 hrs → 133 hrs = </a:t>
+            </a:r>
+            <a:r>
+              <a:rPr sz="1617" b="1">
+                <a:solidFill>
+                  <a:srgbClr val="F6962D"/>
+                </a:solidFill>
+                <a:latin typeface="DejaVu Sans"/>
+              </a:rPr>
+              <a:t>867 hrs SAVED</a:t>
+            </a:r>
+          </a:p>
+        </p:txBody>
+      </p:sp>
+      <p:sp>
+        <p:nvSpPr>
+          <p:cNvPr id="44" name="TextBox 43"/>
+          <p:cNvSpPr txBox="1"/>
+          <p:nvPr/>
+        </p:nvSpPr>
+        <p:spPr>
+          <a:xfrm>
+            <a:off x="790574" y="6098976"/>
+            <a:ext cx="5781674" cy="451842"/>
+          </a:xfrm>
+          <a:prstGeom prst="rect">
+            <a:avLst/>
+          </a:prstGeom>
+          <a:noFill/>
+        </p:spPr>
+        <p:txBody>
+          <a:bodyPr wrap="none" anchor="t" lIns="0" rIns="0" tIns="0" bIns="0">
+            <a:spAutoFit/>
+          </a:bodyPr>
+          <a:lstStyle/>
+          <a:p>
+            <a:pPr algn="l">
+              <a:spcBef>
+                <a:spcPts val="0"/>
+              </a:spcBef>
+              <a:spcAft>
+                <a:spcPts val="0"/>
+              </a:spcAft>
+            </a:pPr>
+            <a:r>
+              <a:rPr sz="1617" b="0">
+                <a:solidFill>
+                  <a:srgbClr val="F9FBFC"/>
+                </a:solidFill>
+                <a:latin typeface="DejaVu Sans"/>
+              </a:rPr>
+              <a:t>Cost: $7,595 - $30,345 per release (at $30/hr)</a:t>
+            </a:r>
+          </a:p>
+        </p:txBody>
+      </p:sp>
+      <p:sp>
+        <p:nvSpPr>
+          <p:cNvPr id="45" name="TextBox 44"/>
+          <p:cNvSpPr txBox="1"/>
+          <p:nvPr/>
+        </p:nvSpPr>
+        <p:spPr>
+          <a:xfrm>
+            <a:off x="1760458" y="6607968"/>
+            <a:ext cx="9528333" cy="294679"/>
+          </a:xfrm>
+          <a:prstGeom prst="rect">
+            <a:avLst/>
+          </a:prstGeom>
+          <a:noFill/>
+        </p:spPr>
+        <p:txBody>
+          <a:bodyPr wrap="none" anchor="t" lIns="0" rIns="0" tIns="0" bIns="0">
+            <a:spAutoFit/>
+          </a:bodyPr>
+          <a:lstStyle/>
+          <a:p>
+            <a:pPr algn="ctr">
+              <a:spcBef>
+                <a:spcPts val="0"/>
+              </a:spcBef>
+              <a:spcAft>
+                <a:spcPts val="0"/>
+              </a:spcAft>
+            </a:pPr>
+            <a:r>
+              <a:rPr sz="1054" b="0">
+                <a:solidFill>
+                  <a:srgbClr val="F9FBFC"/>
+                </a:solidFill>
+                <a:latin typeface="DejaVu Sans"/>
+              </a:rPr>
+              <a:t>Rakesh Boya | Tool Owner &amp; Developer | Honeywell Aerospace | CNS AI Day 2026 | Confidential</a:t>
             </a:r>
           </a:p>
         </p:txBody>

</xml_diff>